<commit_message>
Add interactive graph walkthrough slides
Expand the slide 14–16 deck with a seven-slide click-through guide to graph concepts, including Morph transitions, button links, code examples, and speaker notes. Align the decks and build scripts on the house style by removing manually added RESTRICTED labels.
</commit_message>
<xml_diff>
--- a/multi_agent_systems_slide_1_to_6/Slides-01-06-GIF.pptx
+++ b/multi_agent_systems_slide_1_to_6/Slides-01-06-GIF.pptx
@@ -115,35 +115,35 @@
   <p:extLst>
     <p:ext uri="{521415D9-36F7-43E2-AB2F-B90AF26B5E84}">
       <p14:sectionLst xmlns:p14="http://schemas.microsoft.com/office/powerpoint/2010/main">
-        <p14:section name="1 · Response Codes" id="{4EBB7695-56BF-40F7-B875-38637C028F16}">
+        <p14:section name="1 · Response Codes" id="{C1CE7BD1-2A2E-4DF3-983C-CC3A249F70D3}">
           <p14:sldIdLst>
             <p14:sldId id="256"/>
           </p14:sldIdLst>
         </p14:section>
-        <p14:section name="2 · Why Single Agents Fail" id="{4675FB4A-F305-4581-B576-5B30989241C3}">
+        <p14:section name="2 · Why Single Agents Fail" id="{68428781-C9D6-4D47-9C4D-A8C726138FD6}">
           <p14:sldIdLst>
             <p14:sldId id="299"/>
             <p14:sldId id="300"/>
           </p14:sldIdLst>
         </p14:section>
-        <p14:section name="3 · Why Single Agents Fail – Part 2" id="{82F1E7E5-AABC-4C02-B0EE-1496555E4478}">
+        <p14:section name="3 · Why Single Agents Fail – Part 2" id="{0AA38D7A-014F-49E2-8C3C-A10F7493B6BE}">
           <p14:sldIdLst>
             <p14:sldId id="284"/>
             <p14:sldId id="285"/>
           </p14:sldIdLst>
         </p14:section>
-        <p14:section name="4 · Failure Modes" id="{C4D28382-E2C2-4B96-929D-38B201E9CFE2}">
+        <p14:section name="4 · Failure Modes" id="{513274A2-AA96-4028-8E97-6D0DF19A4753}">
           <p14:sldIdLst>
             <p14:sldId id="288"/>
           </p14:sldIdLst>
         </p14:section>
-        <p14:section name="5 · Root Cause" id="{0FC4997B-D564-4146-B600-45D4F937D91B}">
+        <p14:section name="5 · Root Cause" id="{F7EC6862-F1DA-48D9-A62D-F5B5407A03DF}">
           <p14:sldIdLst>
             <p14:sldId id="289"/>
             <p14:sldId id="294"/>
           </p14:sldIdLst>
         </p14:section>
-        <p14:section name="6 · Core Idea" id="{3F8BE447-128F-474D-A34C-05681F5AF728}">
+        <p14:section name="6 · Core Idea" id="{10180076-7466-4775-A4F0-ACE9DA7514DE}">
           <p14:sldIdLst>
             <p14:sldId id="301"/>
           </p14:sldIdLst>
@@ -1890,46 +1890,7 @@
       </p:sp>
       <p:sp>
         <p:nvSpPr>
-          <p:cNvPr id="5" name="!!restricted"/>
-          <p:cNvSpPr txBox="1"/>
-          <p:nvPr/>
-        </p:nvSpPr>
-        <p:spPr>
-          <a:xfrm>
-            <a:off x="5184648" y="6556248"/>
-            <a:ext cx="1828800" cy="201168"/>
-          </a:xfrm>
-          <a:prstGeom prst="rect">
-            <a:avLst/>
-          </a:prstGeom>
-          <a:noFill/>
-          <a:ln/>
-        </p:spPr>
-        <p:txBody>
-          <a:bodyPr wrap="square" lIns="0" tIns="0" rIns="0" bIns="0" rtlCol="0" anchor="ctr"/>
-          <a:lstStyle/>
-          <a:p>
-            <a:pPr algn="ctr" indent="0" marL="0">
-              <a:buNone/>
-            </a:pPr>
-            <a:r>
-              <a:rPr lang="en-US" sz="800" dirty="0">
-                <a:solidFill>
-                  <a:srgbClr val="7F7F7F"/>
-                </a:solidFill>
-                <a:latin typeface="Arial" pitchFamily="34" charset="0"/>
-                <a:ea typeface="Arial" pitchFamily="34" charset="-122"/>
-                <a:cs typeface="Arial" pitchFamily="34" charset="-120"/>
-              </a:rPr>
-              <a:t>RESTRICTED</a:t>
-            </a:r>
-            <a:endParaRPr lang="en-US" sz="800" dirty="0"/>
-          </a:p>
-        </p:txBody>
-      </p:sp>
-      <p:sp>
-        <p:nvSpPr>
-          <p:cNvPr id="6" name="Text 4"/>
+          <p:cNvPr id="5" name="Text 3"/>
           <p:cNvSpPr txBox="1"/>
           <p:nvPr/>
         </p:nvSpPr>
@@ -1968,7 +1929,7 @@
       </p:sp>
       <p:sp>
         <p:nvSpPr>
-          <p:cNvPr id="7" name="!!jsonbox"/>
+          <p:cNvPr id="6" name="!!jsonbox"/>
           <p:cNvSpPr/>
           <p:nvPr/>
         </p:nvSpPr>
@@ -2005,7 +1966,7 @@
       </p:sp>
       <p:sp>
         <p:nvSpPr>
-          <p:cNvPr id="8" name="!!jsonhi"/>
+          <p:cNvPr id="7" name="!!jsonhi"/>
           <p:cNvSpPr/>
           <p:nvPr/>
         </p:nvSpPr>
@@ -2042,7 +2003,7 @@
       </p:sp>
       <p:sp>
         <p:nvSpPr>
-          <p:cNvPr id="9" name="!!json0"/>
+          <p:cNvPr id="8" name="!!json0"/>
           <p:cNvSpPr txBox="1"/>
           <p:nvPr/>
         </p:nvSpPr>
@@ -2081,7 +2042,7 @@
       </p:sp>
       <p:sp>
         <p:nvSpPr>
-          <p:cNvPr id="10" name="!!json1"/>
+          <p:cNvPr id="9" name="!!json1"/>
           <p:cNvSpPr txBox="1"/>
           <p:nvPr/>
         </p:nvSpPr>
@@ -2120,7 +2081,7 @@
       </p:sp>
       <p:sp>
         <p:nvSpPr>
-          <p:cNvPr id="11" name="!!json2"/>
+          <p:cNvPr id="10" name="!!json2"/>
           <p:cNvSpPr txBox="1"/>
           <p:nvPr/>
         </p:nvSpPr>
@@ -2159,7 +2120,7 @@
       </p:sp>
       <p:sp>
         <p:nvSpPr>
-          <p:cNvPr id="12" name="!!json3"/>
+          <p:cNvPr id="11" name="!!json3"/>
           <p:cNvSpPr txBox="1"/>
           <p:nvPr/>
         </p:nvSpPr>
@@ -2198,7 +2159,7 @@
       </p:sp>
       <p:sp>
         <p:nvSpPr>
-          <p:cNvPr id="13" name="!!json4"/>
+          <p:cNvPr id="12" name="!!json4"/>
           <p:cNvSpPr txBox="1"/>
           <p:nvPr/>
         </p:nvSpPr>
@@ -2237,7 +2198,7 @@
       </p:sp>
       <p:sp>
         <p:nvSpPr>
-          <p:cNvPr id="14" name="!!json5"/>
+          <p:cNvPr id="13" name="!!json5"/>
           <p:cNvSpPr txBox="1"/>
           <p:nvPr/>
         </p:nvSpPr>
@@ -2276,7 +2237,7 @@
       </p:sp>
       <p:sp>
         <p:nvSpPr>
-          <p:cNvPr id="15" name="!!json6"/>
+          <p:cNvPr id="14" name="!!json6"/>
           <p:cNvSpPr txBox="1"/>
           <p:nvPr/>
         </p:nvSpPr>
@@ -2315,7 +2276,7 @@
       </p:sp>
       <p:sp>
         <p:nvSpPr>
-          <p:cNvPr id="16" name="!!json7"/>
+          <p:cNvPr id="15" name="!!json7"/>
           <p:cNvSpPr txBox="1"/>
           <p:nvPr/>
         </p:nvSpPr>
@@ -2354,7 +2315,7 @@
       </p:sp>
       <p:sp>
         <p:nvSpPr>
-          <p:cNvPr id="17" name="!!json8"/>
+          <p:cNvPr id="16" name="!!json8"/>
           <p:cNvSpPr txBox="1"/>
           <p:nvPr/>
         </p:nvSpPr>
@@ -2393,7 +2354,7 @@
       </p:sp>
       <p:sp>
         <p:nvSpPr>
-          <p:cNvPr id="18" name="!!json9"/>
+          <p:cNvPr id="17" name="!!json9"/>
           <p:cNvSpPr txBox="1"/>
           <p:nvPr/>
         </p:nvSpPr>
@@ -2432,7 +2393,7 @@
       </p:sp>
       <p:sp>
         <p:nvSpPr>
-          <p:cNvPr id="19" name="!!json10"/>
+          <p:cNvPr id="18" name="!!json10"/>
           <p:cNvSpPr txBox="1"/>
           <p:nvPr/>
         </p:nvSpPr>
@@ -2471,7 +2432,7 @@
       </p:sp>
       <p:sp>
         <p:nvSpPr>
-          <p:cNvPr id="20" name="!!json11"/>
+          <p:cNvPr id="19" name="!!json11"/>
           <p:cNvSpPr txBox="1"/>
           <p:nvPr/>
         </p:nvSpPr>
@@ -2510,7 +2471,7 @@
       </p:sp>
       <p:sp>
         <p:nvSpPr>
-          <p:cNvPr id="21" name="!!json12"/>
+          <p:cNvPr id="20" name="!!json12"/>
           <p:cNvSpPr txBox="1"/>
           <p:nvPr/>
         </p:nvSpPr>
@@ -2549,7 +2510,7 @@
       </p:sp>
       <p:sp>
         <p:nvSpPr>
-          <p:cNvPr id="22" name="!!json13"/>
+          <p:cNvPr id="21" name="!!json13"/>
           <p:cNvSpPr txBox="1"/>
           <p:nvPr/>
         </p:nvSpPr>
@@ -2588,7 +2549,7 @@
       </p:sp>
       <p:sp>
         <p:nvSpPr>
-          <p:cNvPr id="23" name="!!json14"/>
+          <p:cNvPr id="22" name="!!json14"/>
           <p:cNvSpPr txBox="1"/>
           <p:nvPr/>
         </p:nvSpPr>
@@ -2627,7 +2588,7 @@
       </p:sp>
       <p:sp>
         <p:nvSpPr>
-          <p:cNvPr id="24" name="!!json15"/>
+          <p:cNvPr id="23" name="!!json15"/>
           <p:cNvSpPr txBox="1"/>
           <p:nvPr/>
         </p:nvSpPr>
@@ -2666,7 +2627,7 @@
       </p:sp>
       <p:sp>
         <p:nvSpPr>
-          <p:cNvPr id="25" name="!!json16"/>
+          <p:cNvPr id="24" name="!!json16"/>
           <p:cNvSpPr txBox="1"/>
           <p:nvPr/>
         </p:nvSpPr>
@@ -2705,7 +2666,7 @@
       </p:sp>
       <p:sp>
         <p:nvSpPr>
-          <p:cNvPr id="26" name="!!jsonlbl"/>
+          <p:cNvPr id="25" name="!!jsonlbl"/>
           <p:cNvSpPr/>
           <p:nvPr/>
         </p:nvSpPr>
@@ -2753,7 +2714,7 @@
       </p:sp>
       <p:sp>
         <p:nvSpPr>
-          <p:cNvPr id="27" name="!!jsoncap"/>
+          <p:cNvPr id="26" name="!!jsoncap"/>
           <p:cNvSpPr txBox="1"/>
           <p:nvPr/>
         </p:nvSpPr>
@@ -2806,7 +2767,7 @@
       </p:sp>
       <p:sp>
         <p:nvSpPr>
-          <p:cNvPr id="28" name="Text 26"/>
+          <p:cNvPr id="27" name="Text 25"/>
           <p:cNvSpPr txBox="1"/>
           <p:nvPr/>
         </p:nvSpPr>
@@ -4461,7 +4422,7 @@
       </p:graphicFrame>
       <p:sp>
         <p:nvSpPr>
-          <p:cNvPr id="30" name="!!gemnote"/>
+          <p:cNvPr id="29" name="!!gemnote"/>
           <p:cNvSpPr txBox="1"/>
           <p:nvPr/>
         </p:nvSpPr>
@@ -4500,7 +4461,7 @@
       </p:sp>
       <p:sp>
         <p:nvSpPr>
-          <p:cNvPr id="31" name="Text 28"/>
+          <p:cNvPr id="30" name="Text 27"/>
           <p:cNvSpPr txBox="1"/>
           <p:nvPr/>
         </p:nvSpPr>
@@ -4539,7 +4500,7 @@
       </p:sp>
       <p:sp>
         <p:nvSpPr>
-          <p:cNvPr id="32" name="!!act0"/>
+          <p:cNvPr id="31" name="!!act0"/>
           <p:cNvSpPr/>
           <p:nvPr/>
         </p:nvSpPr>
@@ -4601,7 +4562,7 @@
       </p:sp>
       <p:sp>
         <p:nvSpPr>
-          <p:cNvPr id="33" name="!!act1"/>
+          <p:cNvPr id="32" name="!!act1"/>
           <p:cNvSpPr/>
           <p:nvPr/>
         </p:nvSpPr>
@@ -4663,7 +4624,7 @@
       </p:sp>
       <p:sp>
         <p:nvSpPr>
-          <p:cNvPr id="34" name="!!act2"/>
+          <p:cNvPr id="33" name="!!act2"/>
           <p:cNvSpPr/>
           <p:nvPr/>
         </p:nvSpPr>
@@ -4725,7 +4686,7 @@
       </p:sp>
       <p:sp>
         <p:nvSpPr>
-          <p:cNvPr id="35" name="!!act3"/>
+          <p:cNvPr id="34" name="!!act3"/>
           <p:cNvSpPr/>
           <p:nvPr/>
         </p:nvSpPr>
@@ -4787,7 +4748,7 @@
       </p:sp>
       <p:sp>
         <p:nvSpPr>
-          <p:cNvPr id="36" name="!!bridge1"/>
+          <p:cNvPr id="35" name="!!bridge1"/>
           <p:cNvSpPr/>
           <p:nvPr/>
         </p:nvSpPr>
@@ -5030,46 +4991,7 @@
       </p:sp>
       <p:sp>
         <p:nvSpPr>
-          <p:cNvPr id="5" name="!!restricted"/>
-          <p:cNvSpPr txBox="1"/>
-          <p:nvPr/>
-        </p:nvSpPr>
-        <p:spPr>
-          <a:xfrm>
-            <a:off x="5184648" y="6556248"/>
-            <a:ext cx="1828800" cy="201168"/>
-          </a:xfrm>
-          <a:prstGeom prst="rect">
-            <a:avLst/>
-          </a:prstGeom>
-          <a:noFill/>
-          <a:ln/>
-        </p:spPr>
-        <p:txBody>
-          <a:bodyPr wrap="square" lIns="0" tIns="0" rIns="0" bIns="0" rtlCol="0" anchor="ctr"/>
-          <a:lstStyle/>
-          <a:p>
-            <a:pPr algn="ctr" indent="0" marL="0">
-              <a:buNone/>
-            </a:pPr>
-            <a:r>
-              <a:rPr lang="en-US" sz="800" dirty="0">
-                <a:solidFill>
-                  <a:srgbClr val="7F7F7F"/>
-                </a:solidFill>
-                <a:latin typeface="Arial" pitchFamily="34" charset="0"/>
-                <a:ea typeface="Arial" pitchFamily="34" charset="-122"/>
-                <a:cs typeface="Arial" pitchFamily="34" charset="-120"/>
-              </a:rPr>
-              <a:t>RESTRICTED</a:t>
-            </a:r>
-            <a:endParaRPr lang="en-US" sz="800" dirty="0"/>
-          </a:p>
-        </p:txBody>
-      </p:sp>
-      <p:sp>
-        <p:nvSpPr>
-          <p:cNvPr id="6" name="!!hdm"/>
+          <p:cNvPr id="5" name="!!hdm"/>
           <p:cNvSpPr txBox="1"/>
           <p:nvPr/>
         </p:nvSpPr>
@@ -5108,7 +5030,7 @@
       </p:sp>
       <p:sp>
         <p:nvSpPr>
-          <p:cNvPr id="7" name="!!blk01"/>
+          <p:cNvPr id="6" name="!!blk01"/>
           <p:cNvSpPr/>
           <p:nvPr/>
         </p:nvSpPr>
@@ -5156,7 +5078,7 @@
       </p:sp>
       <p:sp>
         <p:nvSpPr>
-          <p:cNvPr id="8" name="!!tag01"/>
+          <p:cNvPr id="7" name="!!tag01"/>
           <p:cNvSpPr txBox="1"/>
           <p:nvPr/>
         </p:nvSpPr>
@@ -5195,7 +5117,7 @@
       </p:sp>
       <p:sp>
         <p:nvSpPr>
-          <p:cNvPr id="9" name="!!blk02"/>
+          <p:cNvPr id="8" name="!!blk02"/>
           <p:cNvSpPr/>
           <p:nvPr/>
         </p:nvSpPr>
@@ -5243,7 +5165,7 @@
       </p:sp>
       <p:sp>
         <p:nvSpPr>
-          <p:cNvPr id="10" name="!!tag02"/>
+          <p:cNvPr id="9" name="!!tag02"/>
           <p:cNvSpPr txBox="1"/>
           <p:nvPr/>
         </p:nvSpPr>
@@ -5282,7 +5204,7 @@
       </p:sp>
       <p:sp>
         <p:nvSpPr>
-          <p:cNvPr id="11" name="!!blk03"/>
+          <p:cNvPr id="10" name="!!blk03"/>
           <p:cNvSpPr/>
           <p:nvPr/>
         </p:nvSpPr>
@@ -5330,7 +5252,7 @@
       </p:sp>
       <p:sp>
         <p:nvSpPr>
-          <p:cNvPr id="12" name="!!tag03"/>
+          <p:cNvPr id="11" name="!!tag03"/>
           <p:cNvSpPr txBox="1"/>
           <p:nvPr/>
         </p:nvSpPr>
@@ -5369,7 +5291,7 @@
       </p:sp>
       <p:sp>
         <p:nvSpPr>
-          <p:cNvPr id="13" name="!!blk04"/>
+          <p:cNvPr id="12" name="!!blk04"/>
           <p:cNvSpPr/>
           <p:nvPr/>
         </p:nvSpPr>
@@ -5417,7 +5339,7 @@
       </p:sp>
       <p:sp>
         <p:nvSpPr>
-          <p:cNvPr id="14" name="!!tag04"/>
+          <p:cNvPr id="13" name="!!tag04"/>
           <p:cNvSpPr txBox="1"/>
           <p:nvPr/>
         </p:nvSpPr>
@@ -5456,7 +5378,7 @@
       </p:sp>
       <p:sp>
         <p:nvSpPr>
-          <p:cNvPr id="15" name="!!blk05"/>
+          <p:cNvPr id="14" name="!!blk05"/>
           <p:cNvSpPr/>
           <p:nvPr/>
         </p:nvSpPr>
@@ -5504,7 +5426,7 @@
       </p:sp>
       <p:sp>
         <p:nvSpPr>
-          <p:cNvPr id="16" name="!!tag05"/>
+          <p:cNvPr id="15" name="!!tag05"/>
           <p:cNvSpPr txBox="1"/>
           <p:nvPr/>
         </p:nvSpPr>
@@ -5543,7 +5465,7 @@
       </p:sp>
       <p:sp>
         <p:nvSpPr>
-          <p:cNvPr id="17" name="!!blk06"/>
+          <p:cNvPr id="16" name="!!blk06"/>
           <p:cNvSpPr/>
           <p:nvPr/>
         </p:nvSpPr>
@@ -5591,7 +5513,7 @@
       </p:sp>
       <p:sp>
         <p:nvSpPr>
-          <p:cNvPr id="18" name="!!tag06"/>
+          <p:cNvPr id="17" name="!!tag06"/>
           <p:cNvSpPr txBox="1"/>
           <p:nvPr/>
         </p:nvSpPr>
@@ -5630,7 +5552,7 @@
       </p:sp>
       <p:sp>
         <p:nvSpPr>
-          <p:cNvPr id="19" name="!!blk07"/>
+          <p:cNvPr id="18" name="!!blk07"/>
           <p:cNvSpPr/>
           <p:nvPr/>
         </p:nvSpPr>
@@ -5678,7 +5600,7 @@
       </p:sp>
       <p:sp>
         <p:nvSpPr>
-          <p:cNvPr id="20" name="!!tag07"/>
+          <p:cNvPr id="19" name="!!tag07"/>
           <p:cNvSpPr txBox="1"/>
           <p:nvPr/>
         </p:nvSpPr>
@@ -5717,7 +5639,7 @@
       </p:sp>
       <p:sp>
         <p:nvSpPr>
-          <p:cNvPr id="21" name="!!blk08"/>
+          <p:cNvPr id="20" name="!!blk08"/>
           <p:cNvSpPr/>
           <p:nvPr/>
         </p:nvSpPr>
@@ -5765,7 +5687,7 @@
       </p:sp>
       <p:sp>
         <p:nvSpPr>
-          <p:cNvPr id="22" name="!!tag08"/>
+          <p:cNvPr id="21" name="!!tag08"/>
           <p:cNvSpPr txBox="1"/>
           <p:nvPr/>
         </p:nvSpPr>
@@ -5804,7 +5726,7 @@
       </p:sp>
       <p:sp>
         <p:nvSpPr>
-          <p:cNvPr id="23" name="!!blk09"/>
+          <p:cNvPr id="22" name="!!blk09"/>
           <p:cNvSpPr/>
           <p:nvPr/>
         </p:nvSpPr>
@@ -5852,7 +5774,7 @@
       </p:sp>
       <p:sp>
         <p:nvSpPr>
-          <p:cNvPr id="24" name="!!tag09"/>
+          <p:cNvPr id="23" name="!!tag09"/>
           <p:cNvSpPr txBox="1"/>
           <p:nvPr/>
         </p:nvSpPr>
@@ -5891,7 +5813,7 @@
       </p:sp>
       <p:sp>
         <p:nvSpPr>
-          <p:cNvPr id="25" name="!!blk10"/>
+          <p:cNvPr id="24" name="!!blk10"/>
           <p:cNvSpPr/>
           <p:nvPr/>
         </p:nvSpPr>
@@ -5939,7 +5861,7 @@
       </p:sp>
       <p:sp>
         <p:nvSpPr>
-          <p:cNvPr id="26" name="!!tag10"/>
+          <p:cNvPr id="25" name="!!tag10"/>
           <p:cNvSpPr txBox="1"/>
           <p:nvPr/>
         </p:nvSpPr>
@@ -5978,7 +5900,7 @@
       </p:sp>
       <p:sp>
         <p:nvSpPr>
-          <p:cNvPr id="27" name="!!blk11"/>
+          <p:cNvPr id="26" name="!!blk11"/>
           <p:cNvSpPr/>
           <p:nvPr/>
         </p:nvSpPr>
@@ -6026,7 +5948,7 @@
       </p:sp>
       <p:sp>
         <p:nvSpPr>
-          <p:cNvPr id="28" name="!!tag11"/>
+          <p:cNvPr id="27" name="!!tag11"/>
           <p:cNvSpPr txBox="1"/>
           <p:nvPr/>
         </p:nvSpPr>
@@ -6065,7 +5987,7 @@
       </p:sp>
       <p:sp>
         <p:nvSpPr>
-          <p:cNvPr id="29" name="!!blk12"/>
+          <p:cNvPr id="28" name="!!blk12"/>
           <p:cNvSpPr/>
           <p:nvPr/>
         </p:nvSpPr>
@@ -6113,7 +6035,7 @@
       </p:sp>
       <p:sp>
         <p:nvSpPr>
-          <p:cNvPr id="30" name="!!tag12"/>
+          <p:cNvPr id="29" name="!!tag12"/>
           <p:cNvSpPr txBox="1"/>
           <p:nvPr/>
         </p:nvSpPr>
@@ -6152,7 +6074,7 @@
       </p:sp>
       <p:sp>
         <p:nvSpPr>
-          <p:cNvPr id="31" name="!!blk13"/>
+          <p:cNvPr id="30" name="!!blk13"/>
           <p:cNvSpPr/>
           <p:nvPr/>
         </p:nvSpPr>
@@ -6200,7 +6122,7 @@
       </p:sp>
       <p:sp>
         <p:nvSpPr>
-          <p:cNvPr id="32" name="!!tag13"/>
+          <p:cNvPr id="31" name="!!tag13"/>
           <p:cNvSpPr txBox="1"/>
           <p:nvPr/>
         </p:nvSpPr>
@@ -6239,7 +6161,7 @@
       </p:sp>
       <p:sp>
         <p:nvSpPr>
-          <p:cNvPr id="33" name="!!blk14"/>
+          <p:cNvPr id="32" name="!!blk14"/>
           <p:cNvSpPr/>
           <p:nvPr/>
         </p:nvSpPr>
@@ -6287,7 +6209,7 @@
       </p:sp>
       <p:sp>
         <p:nvSpPr>
-          <p:cNvPr id="34" name="!!tag14"/>
+          <p:cNvPr id="33" name="!!tag14"/>
           <p:cNvSpPr txBox="1"/>
           <p:nvPr/>
         </p:nvSpPr>
@@ -6326,7 +6248,7 @@
       </p:sp>
       <p:sp>
         <p:nvSpPr>
-          <p:cNvPr id="35" name="!!blk15"/>
+          <p:cNvPr id="34" name="!!blk15"/>
           <p:cNvSpPr/>
           <p:nvPr/>
         </p:nvSpPr>
@@ -6374,7 +6296,7 @@
       </p:sp>
       <p:sp>
         <p:nvSpPr>
-          <p:cNvPr id="36" name="!!tag15"/>
+          <p:cNvPr id="35" name="!!tag15"/>
           <p:cNvSpPr txBox="1"/>
           <p:nvPr/>
         </p:nvSpPr>
@@ -6413,7 +6335,7 @@
       </p:sp>
       <p:sp>
         <p:nvSpPr>
-          <p:cNvPr id="37" name="!!blk16"/>
+          <p:cNvPr id="36" name="!!blk16"/>
           <p:cNvSpPr/>
           <p:nvPr/>
         </p:nvSpPr>
@@ -6461,7 +6383,7 @@
       </p:sp>
       <p:sp>
         <p:nvSpPr>
-          <p:cNvPr id="38" name="!!tag16"/>
+          <p:cNvPr id="37" name="!!tag16"/>
           <p:cNvSpPr txBox="1"/>
           <p:nvPr/>
         </p:nvSpPr>
@@ -6500,7 +6422,7 @@
       </p:sp>
       <p:sp>
         <p:nvSpPr>
-          <p:cNvPr id="39" name="Text 37"/>
+          <p:cNvPr id="38" name="Text 36"/>
           <p:cNvSpPr txBox="1"/>
           <p:nvPr/>
         </p:nvSpPr>
@@ -6539,7 +6461,7 @@
       </p:sp>
       <p:sp>
         <p:nvSpPr>
-          <p:cNvPr id="40" name="Text 38"/>
+          <p:cNvPr id="39" name="Text 37"/>
           <p:cNvSpPr/>
           <p:nvPr/>
         </p:nvSpPr>
@@ -6576,7 +6498,7 @@
       </p:sp>
       <p:sp>
         <p:nvSpPr>
-          <p:cNvPr id="41" name="Text 39"/>
+          <p:cNvPr id="40" name="Text 38"/>
           <p:cNvSpPr txBox="1"/>
           <p:nvPr/>
         </p:nvSpPr>
@@ -6629,7 +6551,7 @@
       </p:sp>
       <p:sp>
         <p:nvSpPr>
-          <p:cNvPr id="42" name="Text 40"/>
+          <p:cNvPr id="41" name="Text 39"/>
           <p:cNvSpPr/>
           <p:nvPr/>
         </p:nvSpPr>
@@ -6666,7 +6588,7 @@
       </p:sp>
       <p:sp>
         <p:nvSpPr>
-          <p:cNvPr id="43" name="Text 41"/>
+          <p:cNvPr id="42" name="Text 40"/>
           <p:cNvSpPr txBox="1"/>
           <p:nvPr/>
         </p:nvSpPr>
@@ -6719,7 +6641,7 @@
       </p:sp>
       <p:sp>
         <p:nvSpPr>
-          <p:cNvPr id="44" name="Text 42"/>
+          <p:cNvPr id="43" name="Text 41"/>
           <p:cNvSpPr/>
           <p:nvPr/>
         </p:nvSpPr>
@@ -6756,7 +6678,7 @@
       </p:sp>
       <p:sp>
         <p:nvSpPr>
-          <p:cNvPr id="45" name="Text 43"/>
+          <p:cNvPr id="44" name="Text 42"/>
           <p:cNvSpPr txBox="1"/>
           <p:nvPr/>
         </p:nvSpPr>
@@ -6809,7 +6731,7 @@
       </p:sp>
       <p:sp>
         <p:nvSpPr>
-          <p:cNvPr id="46" name="Text 44"/>
+          <p:cNvPr id="45" name="Text 43"/>
           <p:cNvSpPr txBox="1"/>
           <p:nvPr/>
         </p:nvSpPr>
@@ -7055,46 +6977,7 @@
       </p:sp>
       <p:sp>
         <p:nvSpPr>
-          <p:cNvPr id="5" name="!!restricted"/>
-          <p:cNvSpPr txBox="1"/>
-          <p:nvPr/>
-        </p:nvSpPr>
-        <p:spPr>
-          <a:xfrm>
-            <a:off x="5184648" y="6556248"/>
-            <a:ext cx="1828800" cy="201168"/>
-          </a:xfrm>
-          <a:prstGeom prst="rect">
-            <a:avLst/>
-          </a:prstGeom>
-          <a:noFill/>
-          <a:ln/>
-        </p:spPr>
-        <p:txBody>
-          <a:bodyPr wrap="square" lIns="0" tIns="0" rIns="0" bIns="0" rtlCol="0" anchor="ctr"/>
-          <a:lstStyle/>
-          <a:p>
-            <a:pPr algn="ctr" indent="0" marL="0">
-              <a:buNone/>
-            </a:pPr>
-            <a:r>
-              <a:rPr lang="en-US" sz="800" dirty="0">
-                <a:solidFill>
-                  <a:srgbClr val="7F7F7F"/>
-                </a:solidFill>
-                <a:latin typeface="Arial" pitchFamily="34" charset="0"/>
-                <a:ea typeface="Arial" pitchFamily="34" charset="-122"/>
-                <a:cs typeface="Arial" pitchFamily="34" charset="-120"/>
-              </a:rPr>
-              <a:t>RESTRICTED</a:t>
-            </a:r>
-            <a:endParaRPr lang="en-US" sz="800" dirty="0"/>
-          </a:p>
-        </p:txBody>
-      </p:sp>
-      <p:sp>
-        <p:nvSpPr>
-          <p:cNvPr id="6" name="!!lh0"/>
+          <p:cNvPr id="5" name="!!lh0"/>
           <p:cNvSpPr txBox="1"/>
           <p:nvPr/>
         </p:nvSpPr>
@@ -7133,7 +7016,7 @@
       </p:sp>
       <p:sp>
         <p:nvSpPr>
-          <p:cNvPr id="7" name="!!lh1"/>
+          <p:cNvPr id="6" name="!!lh1"/>
           <p:cNvSpPr txBox="1"/>
           <p:nvPr/>
         </p:nvSpPr>
@@ -7172,7 +7055,7 @@
       </p:sp>
       <p:sp>
         <p:nvSpPr>
-          <p:cNvPr id="8" name="!!lh2"/>
+          <p:cNvPr id="7" name="!!lh2"/>
           <p:cNvSpPr txBox="1"/>
           <p:nvPr/>
         </p:nvSpPr>
@@ -7211,7 +7094,7 @@
       </p:sp>
       <p:sp>
         <p:nvSpPr>
-          <p:cNvPr id="9" name="!!blk01"/>
+          <p:cNvPr id="8" name="!!blk01"/>
           <p:cNvSpPr/>
           <p:nvPr/>
         </p:nvSpPr>
@@ -7259,7 +7142,7 @@
       </p:sp>
       <p:sp>
         <p:nvSpPr>
-          <p:cNvPr id="10" name="!!blk02"/>
+          <p:cNvPr id="9" name="!!blk02"/>
           <p:cNvSpPr/>
           <p:nvPr/>
         </p:nvSpPr>
@@ -7307,7 +7190,7 @@
       </p:sp>
       <p:sp>
         <p:nvSpPr>
-          <p:cNvPr id="11" name="!!blk03"/>
+          <p:cNvPr id="10" name="!!blk03"/>
           <p:cNvSpPr/>
           <p:nvPr/>
         </p:nvSpPr>
@@ -7355,7 +7238,7 @@
       </p:sp>
       <p:sp>
         <p:nvSpPr>
-          <p:cNvPr id="12" name="!!blk04"/>
+          <p:cNvPr id="11" name="!!blk04"/>
           <p:cNvSpPr/>
           <p:nvPr/>
         </p:nvSpPr>
@@ -7403,7 +7286,7 @@
       </p:sp>
       <p:sp>
         <p:nvSpPr>
-          <p:cNvPr id="13" name="!!blk05"/>
+          <p:cNvPr id="12" name="!!blk05"/>
           <p:cNvSpPr/>
           <p:nvPr/>
         </p:nvSpPr>
@@ -7451,7 +7334,7 @@
       </p:sp>
       <p:sp>
         <p:nvSpPr>
-          <p:cNvPr id="14" name="!!blk06"/>
+          <p:cNvPr id="13" name="!!blk06"/>
           <p:cNvSpPr/>
           <p:nvPr/>
         </p:nvSpPr>
@@ -7499,7 +7382,7 @@
       </p:sp>
       <p:sp>
         <p:nvSpPr>
-          <p:cNvPr id="15" name="!!blk07"/>
+          <p:cNvPr id="14" name="!!blk07"/>
           <p:cNvSpPr/>
           <p:nvPr/>
         </p:nvSpPr>
@@ -7547,7 +7430,7 @@
       </p:sp>
       <p:sp>
         <p:nvSpPr>
-          <p:cNvPr id="16" name="!!blk08"/>
+          <p:cNvPr id="15" name="!!blk08"/>
           <p:cNvSpPr/>
           <p:nvPr/>
         </p:nvSpPr>
@@ -7595,7 +7478,7 @@
       </p:sp>
       <p:sp>
         <p:nvSpPr>
-          <p:cNvPr id="17" name="!!blk09"/>
+          <p:cNvPr id="16" name="!!blk09"/>
           <p:cNvSpPr/>
           <p:nvPr/>
         </p:nvSpPr>
@@ -7643,7 +7526,7 @@
       </p:sp>
       <p:sp>
         <p:nvSpPr>
-          <p:cNvPr id="18" name="!!blk10"/>
+          <p:cNvPr id="17" name="!!blk10"/>
           <p:cNvSpPr/>
           <p:nvPr/>
         </p:nvSpPr>
@@ -7691,7 +7574,7 @@
       </p:sp>
       <p:sp>
         <p:nvSpPr>
-          <p:cNvPr id="19" name="!!blk11"/>
+          <p:cNvPr id="18" name="!!blk11"/>
           <p:cNvSpPr/>
           <p:nvPr/>
         </p:nvSpPr>
@@ -7739,7 +7622,7 @@
       </p:sp>
       <p:sp>
         <p:nvSpPr>
-          <p:cNvPr id="20" name="!!blk12"/>
+          <p:cNvPr id="19" name="!!blk12"/>
           <p:cNvSpPr/>
           <p:nvPr/>
         </p:nvSpPr>
@@ -7787,7 +7670,7 @@
       </p:sp>
       <p:sp>
         <p:nvSpPr>
-          <p:cNvPr id="21" name="!!blk13"/>
+          <p:cNvPr id="20" name="!!blk13"/>
           <p:cNvSpPr/>
           <p:nvPr/>
         </p:nvSpPr>
@@ -7835,7 +7718,7 @@
       </p:sp>
       <p:sp>
         <p:nvSpPr>
-          <p:cNvPr id="22" name="!!blk14"/>
+          <p:cNvPr id="21" name="!!blk14"/>
           <p:cNvSpPr/>
           <p:nvPr/>
         </p:nvSpPr>
@@ -7883,7 +7766,7 @@
       </p:sp>
       <p:sp>
         <p:nvSpPr>
-          <p:cNvPr id="23" name="!!blk15"/>
+          <p:cNvPr id="22" name="!!blk15"/>
           <p:cNvSpPr/>
           <p:nvPr/>
         </p:nvSpPr>
@@ -7931,7 +7814,7 @@
       </p:sp>
       <p:sp>
         <p:nvSpPr>
-          <p:cNvPr id="24" name="!!blk16"/>
+          <p:cNvPr id="23" name="!!blk16"/>
           <p:cNvSpPr/>
           <p:nvPr/>
         </p:nvSpPr>
@@ -7979,7 +7862,7 @@
       </p:sp>
       <p:sp>
         <p:nvSpPr>
-          <p:cNvPr id="25" name="Text 23"/>
+          <p:cNvPr id="24" name="Text 22"/>
           <p:cNvSpPr txBox="1"/>
           <p:nvPr/>
         </p:nvSpPr>
@@ -8018,7 +7901,7 @@
       </p:sp>
       <p:sp>
         <p:nvSpPr>
-          <p:cNvPr id="26" name="Text 24"/>
+          <p:cNvPr id="25" name="Text 23"/>
           <p:cNvSpPr/>
           <p:nvPr/>
         </p:nvSpPr>
@@ -8055,7 +7938,7 @@
       </p:sp>
       <p:sp>
         <p:nvSpPr>
-          <p:cNvPr id="27" name="Text 25"/>
+          <p:cNvPr id="26" name="Text 24"/>
           <p:cNvSpPr txBox="1"/>
           <p:nvPr/>
         </p:nvSpPr>
@@ -8108,7 +7991,7 @@
       </p:sp>
       <p:sp>
         <p:nvSpPr>
-          <p:cNvPr id="28" name="Text 26"/>
+          <p:cNvPr id="27" name="Text 25"/>
           <p:cNvSpPr/>
           <p:nvPr/>
         </p:nvSpPr>
@@ -8145,7 +8028,7 @@
       </p:sp>
       <p:sp>
         <p:nvSpPr>
-          <p:cNvPr id="29" name="Text 27"/>
+          <p:cNvPr id="28" name="Text 26"/>
           <p:cNvSpPr txBox="1"/>
           <p:nvPr/>
         </p:nvSpPr>
@@ -8198,7 +8081,7 @@
       </p:sp>
       <p:sp>
         <p:nvSpPr>
-          <p:cNvPr id="30" name="Text 28"/>
+          <p:cNvPr id="29" name="Text 27"/>
           <p:cNvSpPr/>
           <p:nvPr/>
         </p:nvSpPr>
@@ -8235,7 +8118,7 @@
       </p:sp>
       <p:sp>
         <p:nvSpPr>
-          <p:cNvPr id="31" name="Text 29"/>
+          <p:cNvPr id="30" name="Text 28"/>
           <p:cNvSpPr txBox="1"/>
           <p:nvPr/>
         </p:nvSpPr>
@@ -8288,7 +8171,7 @@
       </p:sp>
       <p:sp>
         <p:nvSpPr>
-          <p:cNvPr id="32" name="Text 30"/>
+          <p:cNvPr id="31" name="Text 29"/>
           <p:cNvSpPr txBox="1"/>
           <p:nvPr/>
         </p:nvSpPr>
@@ -8341,7 +8224,7 @@
       </p:sp>
       <p:sp>
         <p:nvSpPr>
-          <p:cNvPr id="33" name="!!take3"/>
+          <p:cNvPr id="32" name="!!take3"/>
           <p:cNvSpPr/>
           <p:nvPr/>
         </p:nvSpPr>
@@ -8580,48 +8463,9 @@
           </a:p>
         </p:txBody>
       </p:sp>
-      <p:sp>
-        <p:nvSpPr>
-          <p:cNvPr id="5" name="!!restricted"/>
-          <p:cNvSpPr txBox="1"/>
-          <p:nvPr/>
-        </p:nvSpPr>
-        <p:spPr>
-          <a:xfrm>
-            <a:off x="5184648" y="6556248"/>
-            <a:ext cx="1828800" cy="201168"/>
-          </a:xfrm>
-          <a:prstGeom prst="rect">
-            <a:avLst/>
-          </a:prstGeom>
-          <a:noFill/>
-          <a:ln/>
-        </p:spPr>
-        <p:txBody>
-          <a:bodyPr wrap="square" lIns="0" tIns="0" rIns="0" bIns="0" rtlCol="0" anchor="ctr"/>
-          <a:lstStyle/>
-          <a:p>
-            <a:pPr algn="ctr" indent="0" marL="0">
-              <a:buNone/>
-            </a:pPr>
-            <a:r>
-              <a:rPr lang="en-US" sz="800" dirty="0">
-                <a:solidFill>
-                  <a:srgbClr val="7F7F7F"/>
-                </a:solidFill>
-                <a:latin typeface="Arial" pitchFamily="34" charset="0"/>
-                <a:ea typeface="Arial" pitchFamily="34" charset="-122"/>
-                <a:cs typeface="Arial" pitchFamily="34" charset="-120"/>
-              </a:rPr>
-              <a:t>RESTRICTED</a:t>
-            </a:r>
-            <a:endParaRPr lang="en-US" sz="800" dirty="0"/>
-          </a:p>
-        </p:txBody>
-      </p:sp>
       <p:pic>
         <p:nvPicPr>
-          <p:cNvPr id="6" name="!!fi0" descr="/tmp/deck-icons/TbBrain_534AB7.png">    </p:cNvPr>
+          <p:cNvPr id="5" name="!!fi0" descr="/tmp/deck-icons/TbBrain_534AB7.png">    </p:cNvPr>
           <p:cNvPicPr>
             <a:picLocks noChangeAspect="1"/>
           </p:cNvPicPr>
@@ -8645,7 +8489,7 @@
       </p:pic>
       <p:sp>
         <p:nvSpPr>
-          <p:cNvPr id="7" name="!!fh0"/>
+          <p:cNvPr id="6" name="!!fh0"/>
           <p:cNvSpPr txBox="1"/>
           <p:nvPr/>
         </p:nvSpPr>
@@ -8684,7 +8528,7 @@
       </p:sp>
       <p:sp>
         <p:nvSpPr>
-          <p:cNvPr id="8" name="!!card00"/>
+          <p:cNvPr id="7" name="!!card00"/>
           <p:cNvSpPr/>
           <p:nvPr/>
         </p:nvSpPr>
@@ -8721,7 +8565,7 @@
       </p:sp>
       <p:pic>
         <p:nvPicPr>
-          <p:cNvPr id="9" name="!!ci00" descr="/tmp/deck-icons/TbRouteOff_534AB7.png">    </p:cNvPr>
+          <p:cNvPr id="8" name="!!ci00" descr="/tmp/deck-icons/TbRouteOff_534AB7.png">    </p:cNvPr>
           <p:cNvPicPr>
             <a:picLocks noChangeAspect="1"/>
           </p:cNvPicPr>
@@ -8745,7 +8589,7 @@
       </p:pic>
       <p:sp>
         <p:nvSpPr>
-          <p:cNvPr id="10" name="!!cn00"/>
+          <p:cNvPr id="9" name="!!cn00"/>
           <p:cNvSpPr txBox="1"/>
           <p:nvPr/>
         </p:nvSpPr>
@@ -8784,7 +8628,7 @@
       </p:sp>
       <p:sp>
         <p:nvSpPr>
-          <p:cNvPr id="11" name="!!cb00"/>
+          <p:cNvPr id="10" name="!!cb00"/>
           <p:cNvSpPr txBox="1"/>
           <p:nvPr/>
         </p:nvSpPr>
@@ -8917,7 +8761,7 @@
       </p:sp>
       <p:sp>
         <p:nvSpPr>
-          <p:cNvPr id="12" name="!!card01"/>
+          <p:cNvPr id="11" name="!!card01"/>
           <p:cNvSpPr/>
           <p:nvPr/>
         </p:nvSpPr>
@@ -8954,7 +8798,7 @@
       </p:sp>
       <p:pic>
         <p:nvPicPr>
-          <p:cNvPr id="13" name="!!ci01" descr="/tmp/deck-icons/TbTool_534AB7.png">    </p:cNvPr>
+          <p:cNvPr id="12" name="!!ci01" descr="/tmp/deck-icons/TbTool_534AB7.png">    </p:cNvPr>
           <p:cNvPicPr>
             <a:picLocks noChangeAspect="1"/>
           </p:cNvPicPr>
@@ -8978,7 +8822,7 @@
       </p:pic>
       <p:sp>
         <p:nvSpPr>
-          <p:cNvPr id="14" name="!!cn01"/>
+          <p:cNvPr id="13" name="!!cn01"/>
           <p:cNvSpPr txBox="1"/>
           <p:nvPr/>
         </p:nvSpPr>
@@ -9017,7 +8861,7 @@
       </p:sp>
       <p:sp>
         <p:nvSpPr>
-          <p:cNvPr id="15" name="!!cb01"/>
+          <p:cNvPr id="14" name="!!cb01"/>
           <p:cNvSpPr txBox="1"/>
           <p:nvPr/>
         </p:nvSpPr>
@@ -9150,7 +8994,7 @@
       </p:sp>
       <p:pic>
         <p:nvPicPr>
-          <p:cNvPr id="16" name="!!fi1" descr="/tmp/deck-icons/TbPlayerPlay_0F6E56.png">    </p:cNvPr>
+          <p:cNvPr id="15" name="!!fi1" descr="/tmp/deck-icons/TbPlayerPlay_0F6E56.png">    </p:cNvPr>
           <p:cNvPicPr>
             <a:picLocks noChangeAspect="1"/>
           </p:cNvPicPr>
@@ -9174,7 +9018,7 @@
       </p:pic>
       <p:sp>
         <p:nvSpPr>
-          <p:cNvPr id="17" name="!!fh1"/>
+          <p:cNvPr id="16" name="!!fh1"/>
           <p:cNvSpPr txBox="1"/>
           <p:nvPr/>
         </p:nvSpPr>
@@ -9213,7 +9057,7 @@
       </p:sp>
       <p:sp>
         <p:nvSpPr>
-          <p:cNvPr id="18" name="!!card10"/>
+          <p:cNvPr id="17" name="!!card10"/>
           <p:cNvSpPr/>
           <p:nvPr/>
         </p:nvSpPr>
@@ -9250,7 +9094,7 @@
       </p:sp>
       <p:pic>
         <p:nvPicPr>
-          <p:cNvPr id="19" name="!!ci10" descr="/tmp/deck-icons/TbRepeat_0F6E56.png">    </p:cNvPr>
+          <p:cNvPr id="18" name="!!ci10" descr="/tmp/deck-icons/TbRepeat_0F6E56.png">    </p:cNvPr>
           <p:cNvPicPr>
             <a:picLocks noChangeAspect="1"/>
           </p:cNvPicPr>
@@ -9274,7 +9118,7 @@
       </p:pic>
       <p:sp>
         <p:nvSpPr>
-          <p:cNvPr id="20" name="!!cn10"/>
+          <p:cNvPr id="19" name="!!cn10"/>
           <p:cNvSpPr txBox="1"/>
           <p:nvPr/>
         </p:nvSpPr>
@@ -9313,7 +9157,7 @@
       </p:sp>
       <p:sp>
         <p:nvSpPr>
-          <p:cNvPr id="21" name="!!cb10"/>
+          <p:cNvPr id="20" name="!!cb10"/>
           <p:cNvSpPr txBox="1"/>
           <p:nvPr/>
         </p:nvSpPr>
@@ -9446,7 +9290,7 @@
       </p:sp>
       <p:sp>
         <p:nvSpPr>
-          <p:cNvPr id="22" name="!!card11"/>
+          <p:cNvPr id="21" name="!!card11"/>
           <p:cNvSpPr/>
           <p:nvPr/>
         </p:nvSpPr>
@@ -9483,7 +9327,7 @@
       </p:sp>
       <p:pic>
         <p:nvPicPr>
-          <p:cNvPr id="23" name="!!ci11" descr="/tmp/deck-icons/TbStack2_0F6E56.png">    </p:cNvPr>
+          <p:cNvPr id="22" name="!!ci11" descr="/tmp/deck-icons/TbStack2_0F6E56.png">    </p:cNvPr>
           <p:cNvPicPr>
             <a:picLocks noChangeAspect="1"/>
           </p:cNvPicPr>
@@ -9507,7 +9351,7 @@
       </p:pic>
       <p:sp>
         <p:nvSpPr>
-          <p:cNvPr id="24" name="!!cn11"/>
+          <p:cNvPr id="23" name="!!cn11"/>
           <p:cNvSpPr txBox="1"/>
           <p:nvPr/>
         </p:nvSpPr>
@@ -9546,7 +9390,7 @@
       </p:sp>
       <p:sp>
         <p:nvSpPr>
-          <p:cNvPr id="25" name="!!cb11"/>
+          <p:cNvPr id="24" name="!!cb11"/>
           <p:cNvSpPr txBox="1"/>
           <p:nvPr/>
         </p:nvSpPr>
@@ -9679,7 +9523,7 @@
       </p:sp>
       <p:pic>
         <p:nvPicPr>
-          <p:cNvPr id="26" name="!!fi2" descr="/tmp/deck-icons/TbChecklist_993C1D.png">    </p:cNvPr>
+          <p:cNvPr id="25" name="!!fi2" descr="/tmp/deck-icons/TbChecklist_993C1D.png">    </p:cNvPr>
           <p:cNvPicPr>
             <a:picLocks noChangeAspect="1"/>
           </p:cNvPicPr>
@@ -9703,7 +9547,7 @@
       </p:pic>
       <p:sp>
         <p:nvSpPr>
-          <p:cNvPr id="27" name="!!fh2"/>
+          <p:cNvPr id="26" name="!!fh2"/>
           <p:cNvSpPr txBox="1"/>
           <p:nvPr/>
         </p:nvSpPr>
@@ -9742,7 +9586,7 @@
       </p:sp>
       <p:sp>
         <p:nvSpPr>
-          <p:cNvPr id="28" name="!!card20"/>
+          <p:cNvPr id="27" name="!!card20"/>
           <p:cNvSpPr/>
           <p:nvPr/>
         </p:nvSpPr>
@@ -9779,7 +9623,7 @@
       </p:sp>
       <p:pic>
         <p:nvPicPr>
-          <p:cNvPr id="29" name="!!ci20" descr="/tmp/deck-icons/TbMoodCheck_993C1D.png">    </p:cNvPr>
+          <p:cNvPr id="28" name="!!ci20" descr="/tmp/deck-icons/TbMoodCheck_993C1D.png">    </p:cNvPr>
           <p:cNvPicPr>
             <a:picLocks noChangeAspect="1"/>
           </p:cNvPicPr>
@@ -9803,7 +9647,7 @@
       </p:pic>
       <p:sp>
         <p:nvSpPr>
-          <p:cNvPr id="30" name="!!cn20"/>
+          <p:cNvPr id="29" name="!!cn20"/>
           <p:cNvSpPr txBox="1"/>
           <p:nvPr/>
         </p:nvSpPr>
@@ -9842,7 +9686,7 @@
       </p:sp>
       <p:sp>
         <p:nvSpPr>
-          <p:cNvPr id="31" name="!!cb20"/>
+          <p:cNvPr id="30" name="!!cb20"/>
           <p:cNvSpPr txBox="1"/>
           <p:nvPr/>
         </p:nvSpPr>
@@ -9975,7 +9819,7 @@
       </p:sp>
       <p:sp>
         <p:nvSpPr>
-          <p:cNvPr id="32" name="!!card21"/>
+          <p:cNvPr id="31" name="!!card21"/>
           <p:cNvSpPr/>
           <p:nvPr/>
         </p:nvSpPr>
@@ -10012,7 +9856,7 @@
       </p:sp>
       <p:pic>
         <p:nvPicPr>
-          <p:cNvPr id="33" name="!!ci21" descr="/tmp/deck-icons/TbPlayerStop_993C1D.png">    </p:cNvPr>
+          <p:cNvPr id="32" name="!!ci21" descr="/tmp/deck-icons/TbPlayerStop_993C1D.png">    </p:cNvPr>
           <p:cNvPicPr>
             <a:picLocks noChangeAspect="1"/>
           </p:cNvPicPr>
@@ -10036,7 +9880,7 @@
       </p:pic>
       <p:sp>
         <p:nvSpPr>
-          <p:cNvPr id="34" name="!!cn21"/>
+          <p:cNvPr id="33" name="!!cn21"/>
           <p:cNvSpPr txBox="1"/>
           <p:nvPr/>
         </p:nvSpPr>
@@ -10075,7 +9919,7 @@
       </p:sp>
       <p:sp>
         <p:nvSpPr>
-          <p:cNvPr id="35" name="!!cb21"/>
+          <p:cNvPr id="34" name="!!cb21"/>
           <p:cNvSpPr txBox="1"/>
           <p:nvPr/>
         </p:nvSpPr>
@@ -10208,7 +10052,7 @@
       </p:sp>
       <p:sp>
         <p:nvSpPr>
-          <p:cNvPr id="36" name="!!take4"/>
+          <p:cNvPr id="35" name="!!take4"/>
           <p:cNvSpPr txBox="1"/>
           <p:nvPr/>
         </p:nvSpPr>
@@ -10335,7 +10179,7 @@
                                           </p:stCondLst>
                                         </p:cTn>
                                         <p:tgtEl>
-                                          <p:spTgt spid="16"/>
+                                          <p:spTgt spid="15"/>
                                         </p:tgtEl>
                                         <p:attrNameLst>
                                           <p:attrName>style.visibility</p:attrName>
@@ -10349,7 +10193,7 @@
                                       <p:cBhvr>
                                         <p:cTn id="7" dur="500"/>
                                         <p:tgtEl>
-                                          <p:spTgt spid="16"/>
+                                          <p:spTgt spid="15"/>
                                         </p:tgtEl>
                                       </p:cBhvr>
                                     </p:animEffect>
@@ -10370,7 +10214,7 @@
                                           </p:stCondLst>
                                         </p:cTn>
                                         <p:tgtEl>
-                                          <p:spTgt spid="17"/>
+                                          <p:spTgt spid="16"/>
                                         </p:tgtEl>
                                         <p:attrNameLst>
                                           <p:attrName>style.visibility</p:attrName>
@@ -10384,7 +10228,7 @@
                                       <p:cBhvr>
                                         <p:cTn id="10" dur="500"/>
                                         <p:tgtEl>
-                                          <p:spTgt spid="17"/>
+                                          <p:spTgt spid="16"/>
                                         </p:tgtEl>
                                       </p:cBhvr>
                                     </p:animEffect>
@@ -10405,7 +10249,7 @@
                                           </p:stCondLst>
                                         </p:cTn>
                                         <p:tgtEl>
-                                          <p:spTgt spid="18"/>
+                                          <p:spTgt spid="17"/>
                                         </p:tgtEl>
                                         <p:attrNameLst>
                                           <p:attrName>style.visibility</p:attrName>
@@ -10419,7 +10263,7 @@
                                       <p:cBhvr>
                                         <p:cTn id="13" dur="500"/>
                                         <p:tgtEl>
-                                          <p:spTgt spid="18"/>
+                                          <p:spTgt spid="17"/>
                                         </p:tgtEl>
                                       </p:cBhvr>
                                     </p:animEffect>
@@ -10440,7 +10284,7 @@
                                           </p:stCondLst>
                                         </p:cTn>
                                         <p:tgtEl>
-                                          <p:spTgt spid="19"/>
+                                          <p:spTgt spid="18"/>
                                         </p:tgtEl>
                                         <p:attrNameLst>
                                           <p:attrName>style.visibility</p:attrName>
@@ -10454,7 +10298,7 @@
                                       <p:cBhvr>
                                         <p:cTn id="16" dur="500"/>
                                         <p:tgtEl>
-                                          <p:spTgt spid="19"/>
+                                          <p:spTgt spid="18"/>
                                         </p:tgtEl>
                                       </p:cBhvr>
                                     </p:animEffect>
@@ -10475,7 +10319,7 @@
                                           </p:stCondLst>
                                         </p:cTn>
                                         <p:tgtEl>
-                                          <p:spTgt spid="20"/>
+                                          <p:spTgt spid="19"/>
                                         </p:tgtEl>
                                         <p:attrNameLst>
                                           <p:attrName>style.visibility</p:attrName>
@@ -10489,7 +10333,7 @@
                                       <p:cBhvr>
                                         <p:cTn id="19" dur="500"/>
                                         <p:tgtEl>
-                                          <p:spTgt spid="20"/>
+                                          <p:spTgt spid="19"/>
                                         </p:tgtEl>
                                       </p:cBhvr>
                                     </p:animEffect>
@@ -10510,7 +10354,7 @@
                                           </p:stCondLst>
                                         </p:cTn>
                                         <p:tgtEl>
-                                          <p:spTgt spid="21"/>
+                                          <p:spTgt spid="20"/>
                                         </p:tgtEl>
                                         <p:attrNameLst>
                                           <p:attrName>style.visibility</p:attrName>
@@ -10524,7 +10368,7 @@
                                       <p:cBhvr>
                                         <p:cTn id="22" dur="500"/>
                                         <p:tgtEl>
-                                          <p:spTgt spid="21"/>
+                                          <p:spTgt spid="20"/>
                                         </p:tgtEl>
                                       </p:cBhvr>
                                     </p:animEffect>
@@ -10545,7 +10389,7 @@
                                           </p:stCondLst>
                                         </p:cTn>
                                         <p:tgtEl>
-                                          <p:spTgt spid="22"/>
+                                          <p:spTgt spid="21"/>
                                         </p:tgtEl>
                                         <p:attrNameLst>
                                           <p:attrName>style.visibility</p:attrName>
@@ -10559,7 +10403,7 @@
                                       <p:cBhvr>
                                         <p:cTn id="25" dur="500"/>
                                         <p:tgtEl>
-                                          <p:spTgt spid="22"/>
+                                          <p:spTgt spid="21"/>
                                         </p:tgtEl>
                                       </p:cBhvr>
                                     </p:animEffect>
@@ -10580,7 +10424,7 @@
                                           </p:stCondLst>
                                         </p:cTn>
                                         <p:tgtEl>
-                                          <p:spTgt spid="23"/>
+                                          <p:spTgt spid="22"/>
                                         </p:tgtEl>
                                         <p:attrNameLst>
                                           <p:attrName>style.visibility</p:attrName>
@@ -10594,7 +10438,7 @@
                                       <p:cBhvr>
                                         <p:cTn id="28" dur="500"/>
                                         <p:tgtEl>
-                                          <p:spTgt spid="23"/>
+                                          <p:spTgt spid="22"/>
                                         </p:tgtEl>
                                       </p:cBhvr>
                                     </p:animEffect>
@@ -10615,7 +10459,7 @@
                                           </p:stCondLst>
                                         </p:cTn>
                                         <p:tgtEl>
-                                          <p:spTgt spid="24"/>
+                                          <p:spTgt spid="23"/>
                                         </p:tgtEl>
                                         <p:attrNameLst>
                                           <p:attrName>style.visibility</p:attrName>
@@ -10629,7 +10473,7 @@
                                       <p:cBhvr>
                                         <p:cTn id="31" dur="500"/>
                                         <p:tgtEl>
-                                          <p:spTgt spid="24"/>
+                                          <p:spTgt spid="23"/>
                                         </p:tgtEl>
                                       </p:cBhvr>
                                     </p:animEffect>
@@ -10650,7 +10494,7 @@
                                           </p:stCondLst>
                                         </p:cTn>
                                         <p:tgtEl>
-                                          <p:spTgt spid="25"/>
+                                          <p:spTgt spid="24"/>
                                         </p:tgtEl>
                                         <p:attrNameLst>
                                           <p:attrName>style.visibility</p:attrName>
@@ -10664,7 +10508,7 @@
                                       <p:cBhvr>
                                         <p:cTn id="34" dur="500"/>
                                         <p:tgtEl>
-                                          <p:spTgt spid="25"/>
+                                          <p:spTgt spid="24"/>
                                         </p:tgtEl>
                                       </p:cBhvr>
                                     </p:animEffect>
@@ -10703,7 +10547,7 @@
                                           </p:stCondLst>
                                         </p:cTn>
                                         <p:tgtEl>
-                                          <p:spTgt spid="26"/>
+                                          <p:spTgt spid="25"/>
                                         </p:tgtEl>
                                         <p:attrNameLst>
                                           <p:attrName>style.visibility</p:attrName>
@@ -10717,7 +10561,7 @@
                                       <p:cBhvr>
                                         <p:cTn id="39" dur="500"/>
                                         <p:tgtEl>
-                                          <p:spTgt spid="26"/>
+                                          <p:spTgt spid="25"/>
                                         </p:tgtEl>
                                       </p:cBhvr>
                                     </p:animEffect>
@@ -10738,7 +10582,7 @@
                                           </p:stCondLst>
                                         </p:cTn>
                                         <p:tgtEl>
-                                          <p:spTgt spid="27"/>
+                                          <p:spTgt spid="26"/>
                                         </p:tgtEl>
                                         <p:attrNameLst>
                                           <p:attrName>style.visibility</p:attrName>
@@ -10752,7 +10596,7 @@
                                       <p:cBhvr>
                                         <p:cTn id="42" dur="500"/>
                                         <p:tgtEl>
-                                          <p:spTgt spid="27"/>
+                                          <p:spTgt spid="26"/>
                                         </p:tgtEl>
                                       </p:cBhvr>
                                     </p:animEffect>
@@ -10773,7 +10617,7 @@
                                           </p:stCondLst>
                                         </p:cTn>
                                         <p:tgtEl>
-                                          <p:spTgt spid="28"/>
+                                          <p:spTgt spid="27"/>
                                         </p:tgtEl>
                                         <p:attrNameLst>
                                           <p:attrName>style.visibility</p:attrName>
@@ -10787,7 +10631,7 @@
                                       <p:cBhvr>
                                         <p:cTn id="45" dur="500"/>
                                         <p:tgtEl>
-                                          <p:spTgt spid="28"/>
+                                          <p:spTgt spid="27"/>
                                         </p:tgtEl>
                                       </p:cBhvr>
                                     </p:animEffect>
@@ -10808,7 +10652,7 @@
                                           </p:stCondLst>
                                         </p:cTn>
                                         <p:tgtEl>
-                                          <p:spTgt spid="29"/>
+                                          <p:spTgt spid="28"/>
                                         </p:tgtEl>
                                         <p:attrNameLst>
                                           <p:attrName>style.visibility</p:attrName>
@@ -10822,7 +10666,7 @@
                                       <p:cBhvr>
                                         <p:cTn id="48" dur="500"/>
                                         <p:tgtEl>
-                                          <p:spTgt spid="29"/>
+                                          <p:spTgt spid="28"/>
                                         </p:tgtEl>
                                       </p:cBhvr>
                                     </p:animEffect>
@@ -10843,7 +10687,7 @@
                                           </p:stCondLst>
                                         </p:cTn>
                                         <p:tgtEl>
-                                          <p:spTgt spid="30"/>
+                                          <p:spTgt spid="29"/>
                                         </p:tgtEl>
                                         <p:attrNameLst>
                                           <p:attrName>style.visibility</p:attrName>
@@ -10857,7 +10701,7 @@
                                       <p:cBhvr>
                                         <p:cTn id="51" dur="500"/>
                                         <p:tgtEl>
-                                          <p:spTgt spid="30"/>
+                                          <p:spTgt spid="29"/>
                                         </p:tgtEl>
                                       </p:cBhvr>
                                     </p:animEffect>
@@ -10878,7 +10722,7 @@
                                           </p:stCondLst>
                                         </p:cTn>
                                         <p:tgtEl>
-                                          <p:spTgt spid="31"/>
+                                          <p:spTgt spid="30"/>
                                         </p:tgtEl>
                                         <p:attrNameLst>
                                           <p:attrName>style.visibility</p:attrName>
@@ -10892,7 +10736,7 @@
                                       <p:cBhvr>
                                         <p:cTn id="54" dur="500"/>
                                         <p:tgtEl>
-                                          <p:spTgt spid="31"/>
+                                          <p:spTgt spid="30"/>
                                         </p:tgtEl>
                                       </p:cBhvr>
                                     </p:animEffect>
@@ -10913,7 +10757,7 @@
                                           </p:stCondLst>
                                         </p:cTn>
                                         <p:tgtEl>
-                                          <p:spTgt spid="32"/>
+                                          <p:spTgt spid="31"/>
                                         </p:tgtEl>
                                         <p:attrNameLst>
                                           <p:attrName>style.visibility</p:attrName>
@@ -10927,7 +10771,7 @@
                                       <p:cBhvr>
                                         <p:cTn id="57" dur="500"/>
                                         <p:tgtEl>
-                                          <p:spTgt spid="32"/>
+                                          <p:spTgt spid="31"/>
                                         </p:tgtEl>
                                       </p:cBhvr>
                                     </p:animEffect>
@@ -10948,7 +10792,7 @@
                                           </p:stCondLst>
                                         </p:cTn>
                                         <p:tgtEl>
-                                          <p:spTgt spid="33"/>
+                                          <p:spTgt spid="32"/>
                                         </p:tgtEl>
                                         <p:attrNameLst>
                                           <p:attrName>style.visibility</p:attrName>
@@ -10962,7 +10806,7 @@
                                       <p:cBhvr>
                                         <p:cTn id="60" dur="500"/>
                                         <p:tgtEl>
-                                          <p:spTgt spid="33"/>
+                                          <p:spTgt spid="32"/>
                                         </p:tgtEl>
                                       </p:cBhvr>
                                     </p:animEffect>
@@ -10983,7 +10827,7 @@
                                           </p:stCondLst>
                                         </p:cTn>
                                         <p:tgtEl>
-                                          <p:spTgt spid="34"/>
+                                          <p:spTgt spid="33"/>
                                         </p:tgtEl>
                                         <p:attrNameLst>
                                           <p:attrName>style.visibility</p:attrName>
@@ -10997,7 +10841,7 @@
                                       <p:cBhvr>
                                         <p:cTn id="63" dur="500"/>
                                         <p:tgtEl>
-                                          <p:spTgt spid="34"/>
+                                          <p:spTgt spid="33"/>
                                         </p:tgtEl>
                                       </p:cBhvr>
                                     </p:animEffect>
@@ -11018,7 +10862,7 @@
                                           </p:stCondLst>
                                         </p:cTn>
                                         <p:tgtEl>
-                                          <p:spTgt spid="35"/>
+                                          <p:spTgt spid="34"/>
                                         </p:tgtEl>
                                         <p:attrNameLst>
                                           <p:attrName>style.visibility</p:attrName>
@@ -11032,7 +10876,7 @@
                                       <p:cBhvr>
                                         <p:cTn id="66" dur="500"/>
                                         <p:tgtEl>
-                                          <p:spTgt spid="35"/>
+                                          <p:spTgt spid="34"/>
                                         </p:tgtEl>
                                       </p:cBhvr>
                                     </p:animEffect>
@@ -11053,7 +10897,7 @@
                                           </p:stCondLst>
                                         </p:cTn>
                                         <p:tgtEl>
-                                          <p:spTgt spid="36"/>
+                                          <p:spTgt spid="35"/>
                                         </p:tgtEl>
                                         <p:attrNameLst>
                                           <p:attrName>style.visibility</p:attrName>
@@ -11067,7 +10911,7 @@
                                       <p:cBhvr>
                                         <p:cTn id="69" dur="500"/>
                                         <p:tgtEl>
-                                          <p:spTgt spid="36"/>
+                                          <p:spTgt spid="35"/>
                                         </p:tgtEl>
                                       </p:cBhvr>
                                     </p:animEffect>
@@ -11102,21 +10946,21 @@
       </p:par>
     </p:tnLst>
     <p:bldLst>
+      <p:bldP spid="16" grpId="0" animBg="1"/>
       <p:bldP spid="17" grpId="0" animBg="1"/>
-      <p:bldP spid="18" grpId="0" animBg="1"/>
+      <p:bldP spid="19" grpId="0" animBg="1"/>
       <p:bldP spid="20" grpId="0" animBg="1"/>
       <p:bldP spid="21" grpId="0" animBg="1"/>
-      <p:bldP spid="22" grpId="0" animBg="1"/>
+      <p:bldP spid="23" grpId="0" animBg="1"/>
       <p:bldP spid="24" grpId="0" animBg="1"/>
-      <p:bldP spid="25" grpId="0" animBg="1"/>
+      <p:bldP spid="26" grpId="0" animBg="1"/>
       <p:bldP spid="27" grpId="0" animBg="1"/>
-      <p:bldP spid="28" grpId="0" animBg="1"/>
+      <p:bldP spid="29" grpId="0" animBg="1"/>
       <p:bldP spid="30" grpId="0" animBg="1"/>
       <p:bldP spid="31" grpId="0" animBg="1"/>
-      <p:bldP spid="32" grpId="0" animBg="1"/>
+      <p:bldP spid="33" grpId="0" animBg="1"/>
       <p:bldP spid="34" grpId="0" animBg="1"/>
       <p:bldP spid="35" grpId="0" animBg="1"/>
-      <p:bldP spid="36" grpId="0" animBg="1"/>
     </p:bldLst>
   </p:timing>
 </p:sld>
@@ -11249,46 +11093,7 @@
       </p:sp>
       <p:sp>
         <p:nvSpPr>
-          <p:cNvPr id="5" name="!!restricted"/>
-          <p:cNvSpPr txBox="1"/>
-          <p:nvPr/>
-        </p:nvSpPr>
-        <p:spPr>
-          <a:xfrm>
-            <a:off x="5184648" y="6556248"/>
-            <a:ext cx="1828800" cy="201168"/>
-          </a:xfrm>
-          <a:prstGeom prst="rect">
-            <a:avLst/>
-          </a:prstGeom>
-          <a:noFill/>
-          <a:ln/>
-        </p:spPr>
-        <p:txBody>
-          <a:bodyPr wrap="square" lIns="0" tIns="0" rIns="0" bIns="0" rtlCol="0" anchor="ctr"/>
-          <a:lstStyle/>
-          <a:p>
-            <a:pPr algn="ctr" indent="0" marL="0">
-              <a:buNone/>
-            </a:pPr>
-            <a:r>
-              <a:rPr lang="en-US" sz="800" dirty="0">
-                <a:solidFill>
-                  <a:srgbClr val="7F7F7F"/>
-                </a:solidFill>
-                <a:latin typeface="Arial" pitchFamily="34" charset="0"/>
-                <a:ea typeface="Arial" pitchFamily="34" charset="-122"/>
-                <a:cs typeface="Arial" pitchFamily="34" charset="-120"/>
-              </a:rPr>
-              <a:t>RESTRICTED</a:t>
-            </a:r>
-            <a:endParaRPr lang="en-US" sz="800" dirty="0"/>
-          </a:p>
-        </p:txBody>
-      </p:sp>
-      <p:sp>
-        <p:nvSpPr>
-          <p:cNvPr id="6" name="!!task"/>
+          <p:cNvPr id="5" name="!!task"/>
           <p:cNvSpPr/>
           <p:nvPr/>
         </p:nvSpPr>
@@ -11323,7 +11128,7 @@
       </p:sp>
       <p:pic>
         <p:nvPicPr>
-          <p:cNvPr id="7" name="!!taski" descr="/tmp/deck-icons/TbTicket_2C2C2A.png">    </p:cNvPr>
+          <p:cNvPr id="6" name="!!taski" descr="/tmp/deck-icons/TbTicket_2C2C2A.png">    </p:cNvPr>
           <p:cNvPicPr>
             <a:picLocks noChangeAspect="1"/>
           </p:cNvPicPr>
@@ -11347,7 +11152,7 @@
       </p:pic>
       <p:sp>
         <p:nvSpPr>
-          <p:cNvPr id="8" name="!!taskl"/>
+          <p:cNvPr id="7" name="!!taskl"/>
           <p:cNvSpPr txBox="1"/>
           <p:nvPr/>
         </p:nvSpPr>
@@ -11386,7 +11191,7 @@
       </p:sp>
       <p:sp>
         <p:nvSpPr>
-          <p:cNvPr id="9" name="!!big"/>
+          <p:cNvPr id="8" name="!!big"/>
           <p:cNvSpPr/>
           <p:nvPr/>
         </p:nvSpPr>
@@ -11423,7 +11228,7 @@
       </p:sp>
       <p:sp>
         <p:nvSpPr>
-          <p:cNvPr id="10" name="!!bigl"/>
+          <p:cNvPr id="9" name="!!bigl"/>
           <p:cNvSpPr txBox="1"/>
           <p:nvPr/>
         </p:nvSpPr>
@@ -11462,7 +11267,7 @@
       </p:sp>
       <p:sp>
         <p:nvSpPr>
-          <p:cNvPr id="11" name="!!lt0"/>
+          <p:cNvPr id="10" name="!!lt0"/>
           <p:cNvSpPr/>
           <p:nvPr/>
         </p:nvSpPr>
@@ -11486,7 +11291,7 @@
       </p:sp>
       <p:sp>
         <p:nvSpPr>
-          <p:cNvPr id="12" name="!!fr"/>
+          <p:cNvPr id="11" name="!!fr"/>
           <p:cNvSpPr/>
           <p:nvPr/>
         </p:nvSpPr>
@@ -11534,7 +11339,7 @@
       </p:sp>
       <p:sp>
         <p:nvSpPr>
-          <p:cNvPr id="13" name="!!j0"/>
+          <p:cNvPr id="12" name="!!j0"/>
           <p:cNvSpPr/>
           <p:nvPr/>
         </p:nvSpPr>
@@ -11569,7 +11374,7 @@
       </p:sp>
       <p:pic>
         <p:nvPicPr>
-          <p:cNvPr id="14" name="!!ji0" descr="/tmp/deck-icons/TbBrain_534AB7.png">    </p:cNvPr>
+          <p:cNvPr id="13" name="!!ji0" descr="/tmp/deck-icons/TbBrain_534AB7.png">    </p:cNvPr>
           <p:cNvPicPr>
             <a:picLocks noChangeAspect="1"/>
           </p:cNvPicPr>
@@ -11593,7 +11398,7 @@
       </p:pic>
       <p:sp>
         <p:nvSpPr>
-          <p:cNvPr id="15" name="!!j1"/>
+          <p:cNvPr id="14" name="!!j1"/>
           <p:cNvSpPr/>
           <p:nvPr/>
         </p:nvSpPr>
@@ -11628,7 +11433,7 @@
       </p:sp>
       <p:pic>
         <p:nvPicPr>
-          <p:cNvPr id="16" name="!!ji1" descr="/tmp/deck-icons/TbTool_0F6E56.png">    </p:cNvPr>
+          <p:cNvPr id="15" name="!!ji1" descr="/tmp/deck-icons/TbTool_0F6E56.png">    </p:cNvPr>
           <p:cNvPicPr>
             <a:picLocks noChangeAspect="1"/>
           </p:cNvPicPr>
@@ -11652,7 +11457,7 @@
       </p:pic>
       <p:sp>
         <p:nvSpPr>
-          <p:cNvPr id="17" name="!!j2"/>
+          <p:cNvPr id="16" name="!!j2"/>
           <p:cNvSpPr/>
           <p:nvPr/>
         </p:nvSpPr>
@@ -11687,7 +11492,7 @@
       </p:sp>
       <p:pic>
         <p:nvPicPr>
-          <p:cNvPr id="18" name="!!ji2" descr="/tmp/deck-icons/TbChecklist_993C1D.png">    </p:cNvPr>
+          <p:cNvPr id="17" name="!!ji2" descr="/tmp/deck-icons/TbChecklist_993C1D.png">    </p:cNvPr>
           <p:cNvPicPr>
             <a:picLocks noChangeAspect="1"/>
           </p:cNvPicPr>
@@ -11711,7 +11516,7 @@
       </p:pic>
       <p:sp>
         <p:nvSpPr>
-          <p:cNvPr id="19" name="!!shm"/>
+          <p:cNvPr id="18" name="!!shm"/>
           <p:cNvSpPr/>
           <p:nvPr/>
         </p:nvSpPr>
@@ -11759,7 +11564,7 @@
       </p:sp>
       <p:sp>
         <p:nvSpPr>
-          <p:cNvPr id="20" name="!!sm0"/>
+          <p:cNvPr id="19" name="!!sm0"/>
           <p:cNvSpPr/>
           <p:nvPr/>
         </p:nvSpPr>
@@ -11783,7 +11588,7 @@
       </p:sp>
       <p:sp>
         <p:nvSpPr>
-          <p:cNvPr id="21" name="!!pstep"/>
+          <p:cNvPr id="20" name="!!pstep"/>
           <p:cNvSpPr txBox="1"/>
           <p:nvPr/>
         </p:nvSpPr>
@@ -11822,7 +11627,7 @@
       </p:sp>
       <p:sp>
         <p:nvSpPr>
-          <p:cNvPr id="22" name="!!pname"/>
+          <p:cNvPr id="21" name="!!pname"/>
           <p:cNvSpPr txBox="1"/>
           <p:nvPr/>
         </p:nvSpPr>
@@ -11861,7 +11666,7 @@
       </p:sp>
       <p:sp>
         <p:nvSpPr>
-          <p:cNvPr id="23" name="!!pcap"/>
+          <p:cNvPr id="22" name="!!pcap"/>
           <p:cNvSpPr txBox="1"/>
           <p:nvPr/>
         </p:nvSpPr>
@@ -11900,7 +11705,7 @@
       </p:sp>
       <p:pic>
         <p:nvPicPr>
-          <p:cNvPr id="24" name="!!cki0" descr="/tmp/deck-icons/TbCircle_B4B2A9.png">    </p:cNvPr>
+          <p:cNvPr id="23" name="!!cki0" descr="/tmp/deck-icons/TbCircle_B4B2A9.png">    </p:cNvPr>
           <p:cNvPicPr>
             <a:picLocks noChangeAspect="1"/>
           </p:cNvPicPr>
@@ -11924,7 +11729,7 @@
       </p:pic>
       <p:sp>
         <p:nvSpPr>
-          <p:cNvPr id="25" name="!!ckt0"/>
+          <p:cNvPr id="24" name="!!ckt0"/>
           <p:cNvSpPr txBox="1"/>
           <p:nvPr/>
         </p:nvSpPr>
@@ -11963,7 +11768,7 @@
       </p:sp>
       <p:pic>
         <p:nvPicPr>
-          <p:cNvPr id="26" name="!!cki1" descr="/tmp/deck-icons/TbCircle_B4B2A9.png">    </p:cNvPr>
+          <p:cNvPr id="25" name="!!cki1" descr="/tmp/deck-icons/TbCircle_B4B2A9.png">    </p:cNvPr>
           <p:cNvPicPr>
             <a:picLocks noChangeAspect="1"/>
           </p:cNvPicPr>
@@ -11987,7 +11792,7 @@
       </p:pic>
       <p:sp>
         <p:nvSpPr>
-          <p:cNvPr id="27" name="!!ckt1"/>
+          <p:cNvPr id="26" name="!!ckt1"/>
           <p:cNvSpPr txBox="1"/>
           <p:nvPr/>
         </p:nvSpPr>
@@ -12026,7 +11831,7 @@
       </p:sp>
       <p:pic>
         <p:nvPicPr>
-          <p:cNvPr id="28" name="!!cki2" descr="/tmp/deck-icons/TbCircle_B4B2A9.png">    </p:cNvPr>
+          <p:cNvPr id="27" name="!!cki2" descr="/tmp/deck-icons/TbCircle_B4B2A9.png">    </p:cNvPr>
           <p:cNvPicPr>
             <a:picLocks noChangeAspect="1"/>
           </p:cNvPicPr>
@@ -12050,7 +11855,7 @@
       </p:pic>
       <p:sp>
         <p:nvSpPr>
-          <p:cNvPr id="29" name="!!ckt2"/>
+          <p:cNvPr id="28" name="!!ckt2"/>
           <p:cNvSpPr txBox="1"/>
           <p:nvPr/>
         </p:nvSpPr>
@@ -12089,7 +11894,7 @@
       </p:sp>
       <p:pic>
         <p:nvPicPr>
-          <p:cNvPr id="30" name="!!cki3" descr="/tmp/deck-icons/TbCircle_B4B2A9.png">    </p:cNvPr>
+          <p:cNvPr id="29" name="!!cki3" descr="/tmp/deck-icons/TbCircle_B4B2A9.png">    </p:cNvPr>
           <p:cNvPicPr>
             <a:picLocks noChangeAspect="1"/>
           </p:cNvPicPr>
@@ -12113,7 +11918,7 @@
       </p:pic>
       <p:sp>
         <p:nvSpPr>
-          <p:cNvPr id="31" name="!!ckt3"/>
+          <p:cNvPr id="30" name="!!ckt3"/>
           <p:cNvSpPr txBox="1"/>
           <p:nvPr/>
         </p:nvSpPr>
@@ -12152,7 +11957,7 @@
       </p:sp>
       <p:pic>
         <p:nvPicPr>
-          <p:cNvPr id="32" name="!!cki4" descr="/tmp/deck-icons/TbCircle_B4B2A9.png">    </p:cNvPr>
+          <p:cNvPr id="31" name="!!cki4" descr="/tmp/deck-icons/TbCircle_B4B2A9.png">    </p:cNvPr>
           <p:cNvPicPr>
             <a:picLocks noChangeAspect="1"/>
           </p:cNvPicPr>
@@ -12176,7 +11981,7 @@
       </p:pic>
       <p:sp>
         <p:nvSpPr>
-          <p:cNvPr id="33" name="!!ckt4"/>
+          <p:cNvPr id="32" name="!!ckt4"/>
           <p:cNvSpPr txBox="1"/>
           <p:nvPr/>
         </p:nvSpPr>
@@ -12408,46 +12213,7 @@
       </p:sp>
       <p:sp>
         <p:nvSpPr>
-          <p:cNvPr id="5" name="!!restricted"/>
-          <p:cNvSpPr txBox="1"/>
-          <p:nvPr/>
-        </p:nvSpPr>
-        <p:spPr>
-          <a:xfrm>
-            <a:off x="5184648" y="6556248"/>
-            <a:ext cx="1828800" cy="201168"/>
-          </a:xfrm>
-          <a:prstGeom prst="rect">
-            <a:avLst/>
-          </a:prstGeom>
-          <a:noFill/>
-          <a:ln/>
-        </p:spPr>
-        <p:txBody>
-          <a:bodyPr wrap="square" lIns="0" tIns="0" rIns="0" bIns="0" rtlCol="0" anchor="ctr"/>
-          <a:lstStyle/>
-          <a:p>
-            <a:pPr algn="ctr" indent="0" marL="0">
-              <a:buNone/>
-            </a:pPr>
-            <a:r>
-              <a:rPr lang="en-US" sz="800" dirty="0">
-                <a:solidFill>
-                  <a:srgbClr val="7F7F7F"/>
-                </a:solidFill>
-                <a:latin typeface="Arial" pitchFamily="34" charset="0"/>
-                <a:ea typeface="Arial" pitchFamily="34" charset="-122"/>
-                <a:cs typeface="Arial" pitchFamily="34" charset="-120"/>
-              </a:rPr>
-              <a:t>RESTRICTED</a:t>
-            </a:r>
-            <a:endParaRPr lang="en-US" sz="800" dirty="0"/>
-          </a:p>
-        </p:txBody>
-      </p:sp>
-      <p:sp>
-        <p:nvSpPr>
-          <p:cNvPr id="6" name="!!task"/>
+          <p:cNvPr id="5" name="!!task"/>
           <p:cNvSpPr/>
           <p:nvPr/>
         </p:nvSpPr>
@@ -12482,7 +12248,7 @@
       </p:sp>
       <p:pic>
         <p:nvPicPr>
-          <p:cNvPr id="7" name="!!taski" descr="/tmp/deck-icons/TbTicket_2C2C2A.png">    </p:cNvPr>
+          <p:cNvPr id="6" name="!!taski" descr="/tmp/deck-icons/TbTicket_2C2C2A.png">    </p:cNvPr>
           <p:cNvPicPr>
             <a:picLocks noChangeAspect="1"/>
           </p:cNvPicPr>
@@ -12506,7 +12272,7 @@
       </p:pic>
       <p:sp>
         <p:nvSpPr>
-          <p:cNvPr id="8" name="!!taskl"/>
+          <p:cNvPr id="7" name="!!taskl"/>
           <p:cNvSpPr txBox="1"/>
           <p:nvPr/>
         </p:nvSpPr>
@@ -12545,7 +12311,7 @@
       </p:sp>
       <p:sp>
         <p:nvSpPr>
-          <p:cNvPr id="9" name="!!lt1a"/>
+          <p:cNvPr id="8" name="!!lt1a"/>
           <p:cNvSpPr/>
           <p:nvPr/>
         </p:nvSpPr>
@@ -12568,7 +12334,7 @@
       </p:sp>
       <p:sp>
         <p:nvSpPr>
-          <p:cNvPr id="10" name="!!lt1b"/>
+          <p:cNvPr id="9" name="!!lt1b"/>
           <p:cNvSpPr/>
           <p:nvPr/>
         </p:nvSpPr>
@@ -12592,7 +12358,7 @@
       </p:sp>
       <p:sp>
         <p:nvSpPr>
-          <p:cNvPr id="11" name="!!lpw"/>
+          <p:cNvPr id="10" name="!!lpw"/>
           <p:cNvSpPr/>
           <p:nvPr/>
         </p:nvSpPr>
@@ -12616,7 +12382,7 @@
       </p:sp>
       <p:sp>
         <p:nvSpPr>
-          <p:cNvPr id="12" name="!!lwc"/>
+          <p:cNvPr id="11" name="!!lwc"/>
           <p:cNvSpPr/>
           <p:nvPr/>
         </p:nvSpPr>
@@ -12640,7 +12406,7 @@
       </p:sp>
       <p:sp>
         <p:nvSpPr>
-          <p:cNvPr id="13" name="!!fb1"/>
+          <p:cNvPr id="12" name="!!fb1"/>
           <p:cNvSpPr/>
           <p:nvPr/>
         </p:nvSpPr>
@@ -12663,7 +12429,7 @@
       </p:sp>
       <p:sp>
         <p:nvSpPr>
-          <p:cNvPr id="14" name="!!fb2"/>
+          <p:cNvPr id="13" name="!!fb2"/>
           <p:cNvSpPr/>
           <p:nvPr/>
         </p:nvSpPr>
@@ -12686,7 +12452,7 @@
       </p:sp>
       <p:sp>
         <p:nvSpPr>
-          <p:cNvPr id="15" name="!!fb3"/>
+          <p:cNvPr id="14" name="!!fb3"/>
           <p:cNvSpPr/>
           <p:nvPr/>
         </p:nvSpPr>
@@ -12710,7 +12476,7 @@
       </p:sp>
       <p:sp>
         <p:nvSpPr>
-          <p:cNvPr id="16" name="!!j0"/>
+          <p:cNvPr id="15" name="!!j0"/>
           <p:cNvSpPr/>
           <p:nvPr/>
         </p:nvSpPr>
@@ -12745,7 +12511,7 @@
       </p:sp>
       <p:pic>
         <p:nvPicPr>
-          <p:cNvPr id="17" name="!!ji0" descr="/tmp/deck-icons/TbBrain_534AB7.png">    </p:cNvPr>
+          <p:cNvPr id="16" name="!!ji0" descr="/tmp/deck-icons/TbBrain_534AB7.png">    </p:cNvPr>
           <p:cNvPicPr>
             <a:picLocks noChangeAspect="1"/>
           </p:cNvPicPr>
@@ -12769,7 +12535,7 @@
       </p:pic>
       <p:sp>
         <p:nvSpPr>
-          <p:cNvPr id="18" name="!!jl0"/>
+          <p:cNvPr id="17" name="!!jl0"/>
           <p:cNvSpPr txBox="1"/>
           <p:nvPr/>
         </p:nvSpPr>
@@ -12808,7 +12574,7 @@
       </p:sp>
       <p:sp>
         <p:nvSpPr>
-          <p:cNvPr id="19" name="!!j1"/>
+          <p:cNvPr id="18" name="!!j1"/>
           <p:cNvSpPr/>
           <p:nvPr/>
         </p:nvSpPr>
@@ -12843,7 +12609,7 @@
       </p:sp>
       <p:pic>
         <p:nvPicPr>
-          <p:cNvPr id="20" name="!!ji1" descr="/tmp/deck-icons/TbTool_0F6E56.png">    </p:cNvPr>
+          <p:cNvPr id="19" name="!!ji1" descr="/tmp/deck-icons/TbTool_0F6E56.png">    </p:cNvPr>
           <p:cNvPicPr>
             <a:picLocks noChangeAspect="1"/>
           </p:cNvPicPr>
@@ -12867,7 +12633,7 @@
       </p:pic>
       <p:sp>
         <p:nvSpPr>
-          <p:cNvPr id="21" name="!!jl1"/>
+          <p:cNvPr id="20" name="!!jl1"/>
           <p:cNvSpPr txBox="1"/>
           <p:nvPr/>
         </p:nvSpPr>
@@ -12906,7 +12672,7 @@
       </p:sp>
       <p:sp>
         <p:nvSpPr>
-          <p:cNvPr id="22" name="!!j2"/>
+          <p:cNvPr id="21" name="!!j2"/>
           <p:cNvSpPr/>
           <p:nvPr/>
         </p:nvSpPr>
@@ -12941,7 +12707,7 @@
       </p:sp>
       <p:pic>
         <p:nvPicPr>
-          <p:cNvPr id="23" name="!!ji2" descr="/tmp/deck-icons/TbChecklist_993C1D.png">    </p:cNvPr>
+          <p:cNvPr id="22" name="!!ji2" descr="/tmp/deck-icons/TbChecklist_993C1D.png">    </p:cNvPr>
           <p:cNvPicPr>
             <a:picLocks noChangeAspect="1"/>
           </p:cNvPicPr>
@@ -12965,7 +12731,7 @@
       </p:pic>
       <p:sp>
         <p:nvSpPr>
-          <p:cNvPr id="24" name="!!jl2"/>
+          <p:cNvPr id="23" name="!!jl2"/>
           <p:cNvSpPr txBox="1"/>
           <p:nvPr/>
         </p:nvSpPr>
@@ -13004,7 +12770,7 @@
       </p:sp>
       <p:sp>
         <p:nvSpPr>
-          <p:cNvPr id="25" name="!!own0"/>
+          <p:cNvPr id="24" name="!!own0"/>
           <p:cNvSpPr/>
           <p:nvPr/>
         </p:nvSpPr>
@@ -13052,7 +12818,7 @@
       </p:sp>
       <p:sp>
         <p:nvSpPr>
-          <p:cNvPr id="26" name="!!owl0"/>
+          <p:cNvPr id="25" name="!!owl0"/>
           <p:cNvSpPr/>
           <p:nvPr/>
         </p:nvSpPr>
@@ -13076,7 +12842,7 @@
       </p:sp>
       <p:sp>
         <p:nvSpPr>
-          <p:cNvPr id="27" name="!!own1"/>
+          <p:cNvPr id="26" name="!!own1"/>
           <p:cNvSpPr/>
           <p:nvPr/>
         </p:nvSpPr>
@@ -13124,7 +12890,7 @@
       </p:sp>
       <p:sp>
         <p:nvSpPr>
-          <p:cNvPr id="28" name="!!owl1"/>
+          <p:cNvPr id="27" name="!!owl1"/>
           <p:cNvSpPr/>
           <p:nvPr/>
         </p:nvSpPr>
@@ -13148,7 +12914,7 @@
       </p:sp>
       <p:sp>
         <p:nvSpPr>
-          <p:cNvPr id="29" name="!!own2"/>
+          <p:cNvPr id="28" name="!!own2"/>
           <p:cNvSpPr/>
           <p:nvPr/>
         </p:nvSpPr>
@@ -13196,7 +12962,7 @@
       </p:sp>
       <p:sp>
         <p:nvSpPr>
-          <p:cNvPr id="30" name="!!owl2"/>
+          <p:cNvPr id="29" name="!!owl2"/>
           <p:cNvSpPr/>
           <p:nvPr/>
         </p:nvSpPr>
@@ -13220,7 +12986,7 @@
       </p:sp>
       <p:sp>
         <p:nvSpPr>
-          <p:cNvPr id="31" name="!!retry"/>
+          <p:cNvPr id="30" name="!!retry"/>
           <p:cNvSpPr/>
           <p:nvPr/>
         </p:nvSpPr>
@@ -13268,7 +13034,7 @@
       </p:sp>
       <p:pic>
         <p:nvPicPr>
-          <p:cNvPr id="32" name="!!flag0" descr="/tmp/deck-icons/TbFlag_5F5E5A.png">    </p:cNvPr>
+          <p:cNvPr id="31" name="!!flag0" descr="/tmp/deck-icons/TbFlag_5F5E5A.png">    </p:cNvPr>
           <p:cNvPicPr>
             <a:picLocks noChangeAspect="1"/>
           </p:cNvPicPr>
@@ -13292,7 +13058,7 @@
       </p:pic>
       <p:pic>
         <p:nvPicPr>
-          <p:cNvPr id="33" name="!!flag1" descr="/tmp/deck-icons/TbFlag_5F5E5A.png">    </p:cNvPr>
+          <p:cNvPr id="32" name="!!flag1" descr="/tmp/deck-icons/TbFlag_5F5E5A.png">    </p:cNvPr>
           <p:cNvPicPr>
             <a:picLocks noChangeAspect="1"/>
           </p:cNvPicPr>
@@ -13316,7 +13082,7 @@
       </p:pic>
       <p:sp>
         <p:nvSpPr>
-          <p:cNvPr id="34" name="!!lockc"/>
+          <p:cNvPr id="33" name="!!lockc"/>
           <p:cNvSpPr/>
           <p:nvPr/>
         </p:nvSpPr>
@@ -13351,7 +13117,7 @@
       </p:sp>
       <p:pic>
         <p:nvPicPr>
-          <p:cNvPr id="35" name="!!locki" descr="/tmp/deck-icons/TbLock_993C1D.png">    </p:cNvPr>
+          <p:cNvPr id="34" name="!!locki" descr="/tmp/deck-icons/TbLock_993C1D.png">    </p:cNvPr>
           <p:cNvPicPr>
             <a:picLocks noChangeAspect="1"/>
           </p:cNvPicPr>
@@ -13375,7 +13141,7 @@
       </p:pic>
       <p:sp>
         <p:nvSpPr>
-          <p:cNvPr id="36" name="!!pP"/>
+          <p:cNvPr id="35" name="!!pP"/>
           <p:cNvSpPr/>
           <p:nvPr/>
         </p:nvSpPr>
@@ -13423,7 +13189,7 @@
       </p:sp>
       <p:sp>
         <p:nvSpPr>
-          <p:cNvPr id="37" name="!!pW"/>
+          <p:cNvPr id="36" name="!!pW"/>
           <p:cNvSpPr/>
           <p:nvPr/>
         </p:nvSpPr>
@@ -13471,7 +13237,7 @@
       </p:sp>
       <p:sp>
         <p:nvSpPr>
-          <p:cNvPr id="38" name="!!pF"/>
+          <p:cNvPr id="37" name="!!pF"/>
           <p:cNvSpPr/>
           <p:nvPr/>
         </p:nvSpPr>
@@ -13519,7 +13285,7 @@
       </p:sp>
       <p:sp>
         <p:nvSpPr>
-          <p:cNvPr id="39" name="!!pstep"/>
+          <p:cNvPr id="38" name="!!pstep"/>
           <p:cNvSpPr txBox="1"/>
           <p:nvPr/>
         </p:nvSpPr>
@@ -13558,7 +13324,7 @@
       </p:sp>
       <p:sp>
         <p:nvSpPr>
-          <p:cNvPr id="40" name="!!pname"/>
+          <p:cNvPr id="39" name="!!pname"/>
           <p:cNvSpPr txBox="1"/>
           <p:nvPr/>
         </p:nvSpPr>
@@ -13597,7 +13363,7 @@
       </p:sp>
       <p:sp>
         <p:nvSpPr>
-          <p:cNvPr id="41" name="!!pcap"/>
+          <p:cNvPr id="40" name="!!pcap"/>
           <p:cNvSpPr txBox="1"/>
           <p:nvPr/>
         </p:nvSpPr>
@@ -13636,7 +13402,7 @@
       </p:sp>
       <p:pic>
         <p:nvPicPr>
-          <p:cNvPr id="42" name="!!cki0" descr="/tmp/deck-icons/TbCircleCheck_1D9E75.png">    </p:cNvPr>
+          <p:cNvPr id="41" name="!!cki0" descr="/tmp/deck-icons/TbCircleCheck_1D9E75.png">    </p:cNvPr>
           <p:cNvPicPr>
             <a:picLocks noChangeAspect="1"/>
           </p:cNvPicPr>
@@ -13660,7 +13426,7 @@
       </p:pic>
       <p:sp>
         <p:nvSpPr>
-          <p:cNvPr id="43" name="!!ckt0"/>
+          <p:cNvPr id="42" name="!!ckt0"/>
           <p:cNvSpPr txBox="1"/>
           <p:nvPr/>
         </p:nvSpPr>
@@ -13699,7 +13465,7 @@
       </p:sp>
       <p:pic>
         <p:nvPicPr>
-          <p:cNvPr id="44" name="!!cki1" descr="/tmp/deck-icons/TbCircleCheck_1D9E75.png">    </p:cNvPr>
+          <p:cNvPr id="43" name="!!cki1" descr="/tmp/deck-icons/TbCircleCheck_1D9E75.png">    </p:cNvPr>
           <p:cNvPicPr>
             <a:picLocks noChangeAspect="1"/>
           </p:cNvPicPr>
@@ -13723,7 +13489,7 @@
       </p:pic>
       <p:sp>
         <p:nvSpPr>
-          <p:cNvPr id="45" name="!!ckt1"/>
+          <p:cNvPr id="44" name="!!ckt1"/>
           <p:cNvSpPr txBox="1"/>
           <p:nvPr/>
         </p:nvSpPr>
@@ -13762,7 +13528,7 @@
       </p:sp>
       <p:pic>
         <p:nvPicPr>
-          <p:cNvPr id="46" name="!!cki2" descr="/tmp/deck-icons/TbCircleCheck_1D9E75.png">    </p:cNvPr>
+          <p:cNvPr id="45" name="!!cki2" descr="/tmp/deck-icons/TbCircleCheck_1D9E75.png">    </p:cNvPr>
           <p:cNvPicPr>
             <a:picLocks noChangeAspect="1"/>
           </p:cNvPicPr>
@@ -13786,7 +13552,7 @@
       </p:pic>
       <p:sp>
         <p:nvSpPr>
-          <p:cNvPr id="47" name="!!ckt2"/>
+          <p:cNvPr id="46" name="!!ckt2"/>
           <p:cNvSpPr txBox="1"/>
           <p:nvPr/>
         </p:nvSpPr>
@@ -13825,7 +13591,7 @@
       </p:sp>
       <p:pic>
         <p:nvPicPr>
-          <p:cNvPr id="48" name="!!cki3" descr="/tmp/deck-icons/TbCircleCheck_1D9E75.png">    </p:cNvPr>
+          <p:cNvPr id="47" name="!!cki3" descr="/tmp/deck-icons/TbCircleCheck_1D9E75.png">    </p:cNvPr>
           <p:cNvPicPr>
             <a:picLocks noChangeAspect="1"/>
           </p:cNvPicPr>
@@ -13849,7 +13615,7 @@
       </p:pic>
       <p:sp>
         <p:nvSpPr>
-          <p:cNvPr id="49" name="!!ckt3"/>
+          <p:cNvPr id="48" name="!!ckt3"/>
           <p:cNvSpPr txBox="1"/>
           <p:nvPr/>
         </p:nvSpPr>
@@ -13888,7 +13654,7 @@
       </p:sp>
       <p:pic>
         <p:nvPicPr>
-          <p:cNvPr id="50" name="!!cki4" descr="/tmp/deck-icons/TbCircleCheck_1D9E75.png">    </p:cNvPr>
+          <p:cNvPr id="49" name="!!cki4" descr="/tmp/deck-icons/TbCircleCheck_1D9E75.png">    </p:cNvPr>
           <p:cNvPicPr>
             <a:picLocks noChangeAspect="1"/>
           </p:cNvPicPr>
@@ -13912,7 +13678,7 @@
       </p:pic>
       <p:sp>
         <p:nvSpPr>
-          <p:cNvPr id="51" name="!!ckt4"/>
+          <p:cNvPr id="50" name="!!ckt4"/>
           <p:cNvSpPr txBox="1"/>
           <p:nvPr/>
         </p:nvSpPr>
@@ -13951,7 +13717,7 @@
       </p:sp>
       <p:sp>
         <p:nvSpPr>
-          <p:cNvPr id="52" name="!!take5"/>
+          <p:cNvPr id="51" name="!!take5"/>
           <p:cNvSpPr txBox="1"/>
           <p:nvPr/>
         </p:nvSpPr>
@@ -14214,42 +13980,7 @@
       </p:sp>
       <p:sp>
         <p:nvSpPr>
-          <p:cNvPr id="6" name="TextBox 5"/>
-          <p:cNvSpPr txBox="1"/>
-          <p:nvPr/>
-        </p:nvSpPr>
-        <p:spPr>
-          <a:xfrm>
-            <a:off x="5184648" y="6556248"/>
-            <a:ext cx="1828800" cy="201168"/>
-          </a:xfrm>
-          <a:prstGeom prst="rect">
-            <a:avLst/>
-          </a:prstGeom>
-          <a:noFill/>
-        </p:spPr>
-        <p:txBody>
-          <a:bodyPr wrap="square" lIns="0" rIns="0" tIns="0" bIns="0" anchor="t">
-            <a:spAutoFit/>
-          </a:bodyPr>
-          <a:lstStyle/>
-          <a:p>
-            <a:pPr algn="ctr"/>
-            <a:r>
-              <a:rPr sz="800" b="0" i="0">
-                <a:solidFill>
-                  <a:srgbClr val="7F7F7F"/>
-                </a:solidFill>
-                <a:latin typeface="Arial"/>
-              </a:rPr>
-              <a:t>RESTRICTED</a:t>
-            </a:r>
-          </a:p>
-        </p:txBody>
-      </p:sp>
-      <p:sp>
-        <p:nvSpPr>
-          <p:cNvPr id="7" name="Rounded Rectangle 6"/>
+          <p:cNvPr id="6" name="Rounded Rectangle 5"/>
           <p:cNvSpPr/>
           <p:nvPr/>
         </p:nvSpPr>
@@ -14297,7 +14028,7 @@
       </p:sp>
       <p:pic>
         <p:nvPicPr>
-          <p:cNvPr id="8" name="Picture 7" descr="2-why-single-agents-fail-happy-path.gif"/>
+          <p:cNvPr id="7" name="Picture 6" descr="2-why-single-agents-fail-happy-path.gif"/>
           <p:cNvPicPr>
             <a:picLocks noChangeAspect="1"/>
           </p:cNvPicPr>
@@ -14321,7 +14052,7 @@
       </p:pic>
       <p:sp>
         <p:nvSpPr>
-          <p:cNvPr id="9" name="Rounded Rectangle 8"/>
+          <p:cNvPr id="8" name="Rounded Rectangle 7"/>
           <p:cNvSpPr/>
           <p:nvPr/>
         </p:nvSpPr>
@@ -14379,7 +14110,7 @@
       </p:sp>
       <p:sp>
         <p:nvSpPr>
-          <p:cNvPr id="10" name="TextBox 9"/>
+          <p:cNvPr id="9" name="TextBox 8"/>
           <p:cNvSpPr txBox="1"/>
           <p:nvPr/>
         </p:nvSpPr>
@@ -14577,42 +14308,7 @@
       </p:sp>
       <p:sp>
         <p:nvSpPr>
-          <p:cNvPr id="6" name="TextBox 5"/>
-          <p:cNvSpPr txBox="1"/>
-          <p:nvPr/>
-        </p:nvSpPr>
-        <p:spPr>
-          <a:xfrm>
-            <a:off x="5184648" y="6556248"/>
-            <a:ext cx="1828800" cy="201168"/>
-          </a:xfrm>
-          <a:prstGeom prst="rect">
-            <a:avLst/>
-          </a:prstGeom>
-          <a:noFill/>
-        </p:spPr>
-        <p:txBody>
-          <a:bodyPr wrap="square" lIns="0" rIns="0" tIns="0" bIns="0" anchor="t">
-            <a:spAutoFit/>
-          </a:bodyPr>
-          <a:lstStyle/>
-          <a:p>
-            <a:pPr algn="ctr"/>
-            <a:r>
-              <a:rPr sz="800" b="0" i="0">
-                <a:solidFill>
-                  <a:srgbClr val="7F7F7F"/>
-                </a:solidFill>
-                <a:latin typeface="Arial"/>
-              </a:rPr>
-              <a:t>RESTRICTED</a:t>
-            </a:r>
-          </a:p>
-        </p:txBody>
-      </p:sp>
-      <p:sp>
-        <p:nvSpPr>
-          <p:cNvPr id="7" name="Rounded Rectangle 6"/>
+          <p:cNvPr id="6" name="Rounded Rectangle 5"/>
           <p:cNvSpPr/>
           <p:nvPr/>
         </p:nvSpPr>
@@ -14660,7 +14356,7 @@
       </p:sp>
       <p:pic>
         <p:nvPicPr>
-          <p:cNvPr id="8" name="Picture 7" descr="2-why-single-agents-fail-chaotic-path.gif"/>
+          <p:cNvPr id="7" name="Picture 6" descr="2-why-single-agents-fail-chaotic-path.gif"/>
           <p:cNvPicPr>
             <a:picLocks noChangeAspect="1"/>
           </p:cNvPicPr>
@@ -14684,7 +14380,7 @@
       </p:pic>
       <p:sp>
         <p:nvSpPr>
-          <p:cNvPr id="9" name="Rounded Rectangle 8"/>
+          <p:cNvPr id="8" name="Rounded Rectangle 7"/>
           <p:cNvSpPr/>
           <p:nvPr/>
         </p:nvSpPr>
@@ -14742,7 +14438,7 @@
       </p:sp>
       <p:sp>
         <p:nvSpPr>
-          <p:cNvPr id="10" name="TextBox 9"/>
+          <p:cNvPr id="9" name="TextBox 8"/>
           <p:cNvSpPr txBox="1"/>
           <p:nvPr/>
         </p:nvSpPr>
@@ -14940,42 +14636,7 @@
       </p:sp>
       <p:sp>
         <p:nvSpPr>
-          <p:cNvPr id="6" name="TextBox 5"/>
-          <p:cNvSpPr txBox="1"/>
-          <p:nvPr/>
-        </p:nvSpPr>
-        <p:spPr>
-          <a:xfrm>
-            <a:off x="5184648" y="6556248"/>
-            <a:ext cx="1828800" cy="201168"/>
-          </a:xfrm>
-          <a:prstGeom prst="rect">
-            <a:avLst/>
-          </a:prstGeom>
-          <a:noFill/>
-        </p:spPr>
-        <p:txBody>
-          <a:bodyPr wrap="square" lIns="0" rIns="0" tIns="0" bIns="0" anchor="t">
-            <a:spAutoFit/>
-          </a:bodyPr>
-          <a:lstStyle/>
-          <a:p>
-            <a:pPr algn="ctr"/>
-            <a:r>
-              <a:rPr sz="800" b="0" i="0">
-                <a:solidFill>
-                  <a:srgbClr val="7F7F7F"/>
-                </a:solidFill>
-                <a:latin typeface="Arial"/>
-              </a:rPr>
-              <a:t>RESTRICTED</a:t>
-            </a:r>
-          </a:p>
-        </p:txBody>
-      </p:sp>
-      <p:sp>
-        <p:nvSpPr>
-          <p:cNvPr id="7" name="Rounded Rectangle 6"/>
+          <p:cNvPr id="6" name="Rounded Rectangle 5"/>
           <p:cNvSpPr/>
           <p:nvPr/>
         </p:nvSpPr>
@@ -15023,7 +14684,7 @@
       </p:sp>
       <p:pic>
         <p:nvPicPr>
-          <p:cNvPr id="8" name="Picture 7" descr="6-core-idea.gif"/>
+          <p:cNvPr id="7" name="Picture 6" descr="6-core-idea.gif"/>
           <p:cNvPicPr>
             <a:picLocks noChangeAspect="1"/>
           </p:cNvPicPr>
@@ -15047,7 +14708,7 @@
       </p:pic>
       <p:sp>
         <p:nvSpPr>
-          <p:cNvPr id="9" name="Rounded Rectangle 8"/>
+          <p:cNvPr id="8" name="Rounded Rectangle 7"/>
           <p:cNvSpPr/>
           <p:nvPr/>
         </p:nvSpPr>
@@ -15105,7 +14766,7 @@
       </p:sp>
       <p:sp>
         <p:nvSpPr>
-          <p:cNvPr id="10" name="TextBox 9"/>
+          <p:cNvPr id="9" name="TextBox 8"/>
           <p:cNvSpPr txBox="1"/>
           <p:nvPr/>
         </p:nvSpPr>

</xml_diff>